<commit_message>
build: 「DRAM 현실 파악」 간결형 시안 3장 추가 A2 · B2 · C2 (덱 v1.1, dashboard v2.49.22)
- 기존 시안 A · B · C 유지, 4~6장에 텍스트 · 부수 내용을 줄이고 핵심 그림을 키운 간결형 추가(장당 약 870 → 440자)
- 차트 7종 추가: node_simple_log · node_simple_linear · node_simple_cadence · drivers_big · tug2 · tug2_small · tank_big
- 대시보드 발표자료 탭 장 6개 · 웹 보기 이미지 6장, updates.js, v2.49.22
- outline v1.1 · index · log

Co-Authored-By: Claude Opus 5.5 <noreply@anthropic.com>
Claude-Session: https://claude.ai/code/session_017iaPFUaS5LKCp5R7JUCYhz
</commit_message>
<xml_diff>
--- a/dashboard/public/presentations/dram-reality-options.pptx
+++ b/dashboard/public/presentations/dram-reality-options.pptx
@@ -8,6 +8,9 @@
     <p:sldId id="256" r:id="rId7"/>
     <p:sldId id="257" r:id="rId9"/>
     <p:sldId id="258" r:id="rId10"/>
+    <p:sldId id="259" r:id="rId11"/>
+    <p:sldId id="260" r:id="rId12"/>
+    <p:sldId id="261" r:id="rId13"/>
   </p:sldIdLst>
   <p:sldSz cx="18288000" cy="10287000" type="screen4x3"/>
   <p:notesSz cx="6858000" cy="9144000"/>
@@ -690,6 +693,216 @@
           <a:p>
             <a:r>
               <a:t>[시안 C] 왼쪽 아래 점 줄이 새 노드의 간격(촘촘 → 성김)을 보여 줍니다. 오른쪽은 실물 감각: 요청 1건의 KV가 1M 문맥이면 가속기 1개의 HBM(288GB)을 넘고, 넘친 KV는 DRAM · SSD 계층으로 내려갑니다(Google Next '26 'KV Cache storage tiering across RAM, Local SSD'). 토큰은 2년에 330배, 알고리즘은 토큰당 KV를 MHA 대비 최대 1/37로 줄였습니다.</a:t>
+            </a:r>
+          </a:p>
+        </p:txBody>
+      </p:sp>
+      <p:sp>
+        <p:nvSpPr>
+          <p:cNvPr id="4" name="Slide Number Placeholder 3"/>
+          <p:cNvSpPr>
+            <a:spLocks noGrp="1"/>
+          </p:cNvSpPr>
+          <p:nvPr>
+            <p:ph type="sldNum" idx="5" sz="quarter"/>
+          </p:nvPr>
+        </p:nvSpPr>
+        <p:spPr/>
+      </p:sp>
+    </p:spTree>
+  </p:cSld>
+  <p:clrMapOvr>
+    <a:masterClrMapping/>
+  </p:clrMapOvr>
+</p:notes>
+</file>
+
+<file path=ppt/notesSlides/notesSlide4.xml><?xml version="1.0" encoding="utf-8"?>
+<p:notes xmlns:a="http://schemas.openxmlformats.org/drawingml/2006/main" xmlns:p="http://schemas.openxmlformats.org/presentationml/2006/main" xmlns:r="http://schemas.openxmlformats.org/officeDocument/2006/relationships">
+  <p:cSld>
+    <p:spTree>
+      <p:nvGrpSpPr>
+        <p:cNvPr id="1" name=""/>
+        <p:cNvGrpSpPr/>
+        <p:nvPr/>
+      </p:nvGrpSpPr>
+      <p:grpSpPr>
+        <a:xfrm>
+          <a:off x="0" y="0"/>
+          <a:ext cx="0" cy="0"/>
+          <a:chOff x="0" y="0"/>
+          <a:chExt cx="0" cy="0"/>
+        </a:xfrm>
+      </p:grpSpPr>
+      <p:sp>
+        <p:nvSpPr>
+          <p:cNvPr id="2" name="Slide Image Placeholder 1"/>
+          <p:cNvSpPr>
+            <a:spLocks noGrp="1"/>
+          </p:cNvSpPr>
+          <p:nvPr>
+            <p:ph type="sldImg" idx="2"/>
+          </p:nvPr>
+        </p:nvSpPr>
+        <p:spPr/>
+      </p:sp>
+      <p:sp>
+        <p:nvSpPr>
+          <p:cNvPr id="3" name="Notes Placeholder 2"/>
+          <p:cNvSpPr>
+            <a:spLocks noGrp="1"/>
+          </p:cNvSpPr>
+          <p:nvPr>
+            <p:ph type="body" idx="3" sz="quarter"/>
+          </p:nvPr>
+        </p:nvSpPr>
+        <p:spPr/>
+        <p:txBody>
+          <a:bodyPr/>
+          <a:lstStyle/>
+          <a:p>
+            <a:r>
+              <a:t>[간결형] 1~3장의 같은 근거를 핵심 그림만 남겨 다시 그렸습니다. 노드 추이의 기울기(연 -15% → -6%)와 2026년 각 사 위치(격차 3세대), 알고리즘이 토큰당 KV를 32분의 1로 줄이는 동안(70B 기준 MHA BF16 → GQA FP4) 토큰은 2년에 330배 늘었고, 메모리 공급의 실질 증가는 2028년이라는 것이 요지입니다.</a:t>
+            </a:r>
+          </a:p>
+        </p:txBody>
+      </p:sp>
+      <p:sp>
+        <p:nvSpPr>
+          <p:cNvPr id="4" name="Slide Number Placeholder 3"/>
+          <p:cNvSpPr>
+            <a:spLocks noGrp="1"/>
+          </p:cNvSpPr>
+          <p:nvPr>
+            <p:ph type="sldNum" idx="5" sz="quarter"/>
+          </p:nvPr>
+        </p:nvSpPr>
+        <p:spPr/>
+      </p:sp>
+    </p:spTree>
+  </p:cSld>
+  <p:clrMapOvr>
+    <a:masterClrMapping/>
+  </p:clrMapOvr>
+</p:notes>
+</file>
+
+<file path=ppt/notesSlides/notesSlide5.xml><?xml version="1.0" encoding="utf-8"?>
+<p:notes xmlns:a="http://schemas.openxmlformats.org/drawingml/2006/main" xmlns:p="http://schemas.openxmlformats.org/presentationml/2006/main" xmlns:r="http://schemas.openxmlformats.org/officeDocument/2006/relationships">
+  <p:cSld>
+    <p:spTree>
+      <p:nvGrpSpPr>
+        <p:cNvPr id="1" name=""/>
+        <p:cNvGrpSpPr/>
+        <p:nvPr/>
+      </p:nvGrpSpPr>
+      <p:grpSpPr>
+        <a:xfrm>
+          <a:off x="0" y="0"/>
+          <a:ext cx="0" cy="0"/>
+          <a:chOff x="0" y="0"/>
+          <a:chExt cx="0" cy="0"/>
+        </a:xfrm>
+      </p:grpSpPr>
+      <p:sp>
+        <p:nvSpPr>
+          <p:cNvPr id="2" name="Slide Image Placeholder 1"/>
+          <p:cNvSpPr>
+            <a:spLocks noGrp="1"/>
+          </p:cNvSpPr>
+          <p:nvPr>
+            <p:ph type="sldImg" idx="2"/>
+          </p:nvPr>
+        </p:nvSpPr>
+        <p:spPr/>
+      </p:sp>
+      <p:sp>
+        <p:nvSpPr>
+          <p:cNvPr id="3" name="Notes Placeholder 2"/>
+          <p:cNvSpPr>
+            <a:spLocks noGrp="1"/>
+          </p:cNvSpPr>
+          <p:nvPr>
+            <p:ph type="body" idx="3" sz="quarter"/>
+          </p:nvPr>
+        </p:nvSpPr>
+        <p:spPr/>
+        <p:txBody>
+          <a:bodyPr/>
+          <a:lstStyle/>
+          <a:p>
+            <a:r>
+              <a:t>[간결형] 1~3장의 같은 근거를 핵심 그림만 남겨 다시 그렸습니다. 노드 추이의 기울기(연 -15% → -6%)와 2026년 각 사 위치(격차 3세대), 알고리즘이 토큰당 KV를 32분의 1로 줄이는 동안(70B 기준 MHA BF16 → GQA FP4) 토큰은 2년에 330배 늘었고, 메모리 공급의 실질 증가는 2028년이라는 것이 요지입니다.</a:t>
+            </a:r>
+          </a:p>
+        </p:txBody>
+      </p:sp>
+      <p:sp>
+        <p:nvSpPr>
+          <p:cNvPr id="4" name="Slide Number Placeholder 3"/>
+          <p:cNvSpPr>
+            <a:spLocks noGrp="1"/>
+          </p:cNvSpPr>
+          <p:nvPr>
+            <p:ph type="sldNum" idx="5" sz="quarter"/>
+          </p:nvPr>
+        </p:nvSpPr>
+        <p:spPr/>
+      </p:sp>
+    </p:spTree>
+  </p:cSld>
+  <p:clrMapOvr>
+    <a:masterClrMapping/>
+  </p:clrMapOvr>
+</p:notes>
+</file>
+
+<file path=ppt/notesSlides/notesSlide6.xml><?xml version="1.0" encoding="utf-8"?>
+<p:notes xmlns:a="http://schemas.openxmlformats.org/drawingml/2006/main" xmlns:p="http://schemas.openxmlformats.org/presentationml/2006/main" xmlns:r="http://schemas.openxmlformats.org/officeDocument/2006/relationships">
+  <p:cSld>
+    <p:spTree>
+      <p:nvGrpSpPr>
+        <p:cNvPr id="1" name=""/>
+        <p:cNvGrpSpPr/>
+        <p:nvPr/>
+      </p:nvGrpSpPr>
+      <p:grpSpPr>
+        <a:xfrm>
+          <a:off x="0" y="0"/>
+          <a:ext cx="0" cy="0"/>
+          <a:chOff x="0" y="0"/>
+          <a:chExt cx="0" cy="0"/>
+        </a:xfrm>
+      </p:grpSpPr>
+      <p:sp>
+        <p:nvSpPr>
+          <p:cNvPr id="2" name="Slide Image Placeholder 1"/>
+          <p:cNvSpPr>
+            <a:spLocks noGrp="1"/>
+          </p:cNvSpPr>
+          <p:nvPr>
+            <p:ph type="sldImg" idx="2"/>
+          </p:nvPr>
+        </p:nvSpPr>
+        <p:spPr/>
+      </p:sp>
+      <p:sp>
+        <p:nvSpPr>
+          <p:cNvPr id="3" name="Notes Placeholder 2"/>
+          <p:cNvSpPr>
+            <a:spLocks noGrp="1"/>
+          </p:cNvSpPr>
+          <p:nvPr>
+            <p:ph type="body" idx="3" sz="quarter"/>
+          </p:nvPr>
+        </p:nvSpPr>
+        <p:spPr/>
+        <p:txBody>
+          <a:bodyPr/>
+          <a:lstStyle/>
+          <a:p>
+            <a:r>
+              <a:t>[간결형] 1~3장의 같은 근거를 핵심 그림만 남겨 다시 그렸습니다. 노드 추이의 기울기(연 -15% → -6%)와 2026년 각 사 위치(격차 3세대), 알고리즘이 토큰당 KV를 32분의 1로 줄이는 동안(70B 기준 MHA BF16 → GQA FP4) 토큰은 2년에 330배 늘었고, 메모리 공급의 실질 증가는 2028년이라는 것이 요지입니다.</a:t>
             </a:r>
           </a:p>
         </p:txBody>
@@ -3740,7 +3953,7 @@
                 <a:latin typeface="Arial"/>
                 <a:ea typeface="Arial"/>
               </a:rPr>
-              <a:t>   1 / 3  현실 파악 · 시안 A 흐름형</a:t>
+              <a:t>   1 / 6  현실 파악 · 시안 A 흐름형</a:t>
             </a:r>
           </a:p>
         </p:txBody>
@@ -6596,7 +6809,7 @@
                 <a:latin typeface="Arial"/>
                 <a:ea typeface="Arial"/>
               </a:rPr>
-              <a:t>   2 / 3  현실 파악 · 시안 B 선순환형</a:t>
+              <a:t>   2 / 6  현실 파악 · 시안 B 선순환형</a:t>
             </a:r>
           </a:p>
         </p:txBody>
@@ -8672,7 +8885,7 @@
                 <a:latin typeface="Arial"/>
                 <a:ea typeface="Arial"/>
               </a:rPr>
-              <a:t>   3 / 3  현실 파악 · 시안 C 실물형</a:t>
+              <a:t>   3 / 6  현실 파악 · 시안 C 실물형</a:t>
             </a:r>
           </a:p>
         </p:txBody>
@@ -10803,6 +11016,3912 @@
                 <a:ea typeface="Arial"/>
               </a:rPr>
               <a:t>시안 C</a:t>
+            </a:r>
+          </a:p>
+        </p:txBody>
+      </p:sp>
+    </p:spTree>
+  </p:cSld>
+  <p:clrMapOvr>
+    <a:masterClrMapping/>
+  </p:clrMapOvr>
+</p:sld>
+</file>
+
+<file path=ppt/slides/slide4.xml><?xml version="1.0" encoding="utf-8"?>
+<p:sld xmlns:a="http://schemas.openxmlformats.org/drawingml/2006/main" xmlns:p="http://schemas.openxmlformats.org/presentationml/2006/main" xmlns:r="http://schemas.openxmlformats.org/officeDocument/2006/relationships">
+  <p:cSld>
+    <p:spTree>
+      <p:nvGrpSpPr>
+        <p:cNvPr id="1" name=""/>
+        <p:cNvGrpSpPr/>
+        <p:nvPr/>
+      </p:nvGrpSpPr>
+      <p:grpSpPr/>
+      <p:sp>
+        <p:nvSpPr>
+          <p:cNvPr id="2" name="TextBox 1"/>
+          <p:cNvSpPr txBox="1"/>
+          <p:nvPr/>
+        </p:nvSpPr>
+        <p:spPr>
+          <a:xfrm>
+            <a:off x="722376" y="365760"/>
+            <a:ext cx="10972800" cy="329184"/>
+          </a:xfrm>
+          <a:prstGeom prst="rect">
+            <a:avLst/>
+          </a:prstGeom>
+          <a:noFill/>
+        </p:spPr>
+        <p:txBody>
+          <a:bodyPr wrap="square" anchor="t" lIns="0" rIns="0" tIns="0" bIns="0">
+            <a:spAutoFit/>
+          </a:bodyPr>
+          <a:lstStyle/>
+          <a:p>
+            <a:pPr algn="l">
+              <a:lnSpc>
+                <a:spcPct val="110000"/>
+              </a:lnSpc>
+            </a:pPr>
+            <a:r>
+              <a:rPr sz="1800" b="1">
+                <a:solidFill>
+                  <a:srgbClr val="3C4FA5"/>
+                </a:solidFill>
+                <a:latin typeface="Arial"/>
+                <a:ea typeface="Arial"/>
+              </a:rPr>
+              <a:t>DRAM 기술 경쟁력 제고 · 차별화 준비</a:t>
+            </a:r>
+            <a:r>
+              <a:rPr sz="1800" b="0">
+                <a:solidFill>
+                  <a:srgbClr val="555555"/>
+                </a:solidFill>
+                <a:latin typeface="Arial"/>
+                <a:ea typeface="Arial"/>
+              </a:rPr>
+              <a:t>   4 / 6  현실 파악 · 시안 A2 흐름형 간결</a:t>
+            </a:r>
+          </a:p>
+        </p:txBody>
+      </p:sp>
+      <p:sp>
+        <p:nvSpPr>
+          <p:cNvPr id="3" name="TextBox 2"/>
+          <p:cNvSpPr txBox="1"/>
+          <p:nvPr/>
+        </p:nvSpPr>
+        <p:spPr>
+          <a:xfrm>
+            <a:off x="12079224" y="365760"/>
+            <a:ext cx="5486400" cy="329184"/>
+          </a:xfrm>
+          <a:prstGeom prst="rect">
+            <a:avLst/>
+          </a:prstGeom>
+          <a:noFill/>
+        </p:spPr>
+        <p:txBody>
+          <a:bodyPr wrap="square" anchor="t" lIns="0" rIns="0" tIns="0" bIns="0">
+            <a:spAutoFit/>
+          </a:bodyPr>
+          <a:lstStyle/>
+          <a:p>
+            <a:pPr algn="r">
+              <a:lnSpc>
+                <a:spcPct val="110000"/>
+              </a:lnSpc>
+            </a:pPr>
+            <a:r>
+              <a:rPr sz="1800" b="0">
+                <a:solidFill>
+                  <a:srgbClr val="555555"/>
+                </a:solidFill>
+                <a:latin typeface="Arial"/>
+                <a:ea typeface="Arial"/>
+              </a:rPr>
+              <a:t>[문서등급 표기]</a:t>
+            </a:r>
+          </a:p>
+        </p:txBody>
+      </p:sp>
+      <p:sp>
+        <p:nvSpPr>
+          <p:cNvPr id="4" name="TextBox 3"/>
+          <p:cNvSpPr txBox="1"/>
+          <p:nvPr/>
+        </p:nvSpPr>
+        <p:spPr>
+          <a:xfrm>
+            <a:off x="722376" y="786384"/>
+            <a:ext cx="16843248" cy="1024128"/>
+          </a:xfrm>
+          <a:prstGeom prst="rect">
+            <a:avLst/>
+          </a:prstGeom>
+          <a:noFill/>
+        </p:spPr>
+        <p:txBody>
+          <a:bodyPr wrap="square" anchor="ctr" lIns="0" rIns="0" tIns="0" bIns="0">
+            <a:spAutoFit/>
+          </a:bodyPr>
+          <a:lstStyle/>
+          <a:p>
+            <a:pPr algn="l">
+              <a:lnSpc>
+                <a:spcPct val="105000"/>
+              </a:lnSpc>
+            </a:pPr>
+            <a:r>
+              <a:rPr sz="3200" b="1">
+                <a:solidFill>
+                  <a:srgbClr val="1A1A1A"/>
+                </a:solidFill>
+                <a:latin typeface="Arial"/>
+                <a:ea typeface="Arial"/>
+              </a:rPr>
+              <a:t>DRAM은 Shrink 장벽에 막혀 후발 주자의 추격을 받고 있지만,</a:t>
+            </a:r>
+          </a:p>
+          <a:p>
+            <a:pPr algn="l">
+              <a:lnSpc>
+                <a:spcPct val="105000"/>
+              </a:lnSpc>
+            </a:pPr>
+            <a:r>
+              <a:rPr sz="3200" b="1">
+                <a:solidFill>
+                  <a:srgbClr val="1A1A1A"/>
+                </a:solidFill>
+                <a:latin typeface="Arial"/>
+                <a:ea typeface="Arial"/>
+              </a:rPr>
+              <a:t>AI 추론의 병목이 연산에서 메모리로 옮겨 오며 차별화의 기회가 열리고 있다</a:t>
+            </a:r>
+          </a:p>
+        </p:txBody>
+      </p:sp>
+      <p:sp>
+        <p:nvSpPr>
+          <p:cNvPr id="5" name="Rectangle 4"/>
+          <p:cNvSpPr/>
+          <p:nvPr/>
+        </p:nvSpPr>
+        <p:spPr>
+          <a:xfrm>
+            <a:off x="722376" y="1938528"/>
+            <a:ext cx="16843248" cy="18288"/>
+          </a:xfrm>
+          <a:prstGeom prst="rect">
+            <a:avLst/>
+          </a:prstGeom>
+          <a:solidFill>
+            <a:srgbClr val="D9D9D9"/>
+          </a:solidFill>
+          <a:ln>
+            <a:noFill/>
+          </a:ln>
+          <a:effectLst/>
+        </p:spPr>
+        <p:style>
+          <a:lnRef idx="1">
+            <a:schemeClr val="accent1"/>
+          </a:lnRef>
+          <a:fillRef idx="3">
+            <a:schemeClr val="accent1"/>
+          </a:fillRef>
+          <a:effectRef idx="2">
+            <a:schemeClr val="accent1"/>
+          </a:effectRef>
+          <a:fontRef idx="minor">
+            <a:schemeClr val="lt1"/>
+          </a:fontRef>
+        </p:style>
+        <p:txBody>
+          <a:bodyPr rtlCol="0" anchor="ctr"/>
+          <a:lstStyle/>
+          <a:p>
+            <a:pPr algn="ctr"/>
+          </a:p>
+        </p:txBody>
+      </p:sp>
+      <p:sp>
+        <p:nvSpPr>
+          <p:cNvPr id="6" name="Rectangle 5"/>
+          <p:cNvSpPr/>
+          <p:nvPr/>
+        </p:nvSpPr>
+        <p:spPr>
+          <a:xfrm>
+            <a:off x="9015984" y="2194560"/>
+            <a:ext cx="18288" cy="6419088"/>
+          </a:xfrm>
+          <a:prstGeom prst="rect">
+            <a:avLst/>
+          </a:prstGeom>
+          <a:solidFill>
+            <a:srgbClr val="D9D9D9"/>
+          </a:solidFill>
+          <a:ln>
+            <a:noFill/>
+          </a:ln>
+          <a:effectLst/>
+        </p:spPr>
+        <p:style>
+          <a:lnRef idx="1">
+            <a:schemeClr val="accent1"/>
+          </a:lnRef>
+          <a:fillRef idx="3">
+            <a:schemeClr val="accent1"/>
+          </a:fillRef>
+          <a:effectRef idx="2">
+            <a:schemeClr val="accent1"/>
+          </a:effectRef>
+          <a:fontRef idx="minor">
+            <a:schemeClr val="lt1"/>
+          </a:fontRef>
+        </p:style>
+        <p:txBody>
+          <a:bodyPr rtlCol="0" anchor="ctr"/>
+          <a:lstStyle/>
+          <a:p>
+            <a:pPr algn="ctr"/>
+          </a:p>
+        </p:txBody>
+      </p:sp>
+      <p:sp>
+        <p:nvSpPr>
+          <p:cNvPr id="7" name="Oval 6"/>
+          <p:cNvSpPr/>
+          <p:nvPr/>
+        </p:nvSpPr>
+        <p:spPr>
+          <a:xfrm>
+            <a:off x="722376" y="2139696"/>
+            <a:ext cx="438912" cy="438912"/>
+          </a:xfrm>
+          <a:prstGeom prst="ellipse">
+            <a:avLst/>
+          </a:prstGeom>
+          <a:solidFill>
+            <a:srgbClr val="E8590C"/>
+          </a:solidFill>
+          <a:ln>
+            <a:noFill/>
+          </a:ln>
+          <a:effectLst/>
+        </p:spPr>
+        <p:style>
+          <a:lnRef idx="1">
+            <a:schemeClr val="accent1"/>
+          </a:lnRef>
+          <a:fillRef idx="3">
+            <a:schemeClr val="accent1"/>
+          </a:fillRef>
+          <a:effectRef idx="2">
+            <a:schemeClr val="accent1"/>
+          </a:effectRef>
+          <a:fontRef idx="minor">
+            <a:schemeClr val="lt1"/>
+          </a:fontRef>
+        </p:style>
+        <p:txBody>
+          <a:bodyPr rtlCol="0" anchor="ctr"/>
+          <a:lstStyle/>
+          <a:p>
+            <a:pPr algn="ctr"/>
+          </a:p>
+        </p:txBody>
+      </p:sp>
+      <p:sp>
+        <p:nvSpPr>
+          <p:cNvPr id="8" name="TextBox 7"/>
+          <p:cNvSpPr txBox="1"/>
+          <p:nvPr/>
+        </p:nvSpPr>
+        <p:spPr>
+          <a:xfrm>
+            <a:off x="722376" y="2139696"/>
+            <a:ext cx="438912" cy="438912"/>
+          </a:xfrm>
+          <a:prstGeom prst="rect">
+            <a:avLst/>
+          </a:prstGeom>
+          <a:noFill/>
+        </p:spPr>
+        <p:txBody>
+          <a:bodyPr wrap="square" anchor="ctr" lIns="0" rIns="0" tIns="0" bIns="0">
+            <a:spAutoFit/>
+          </a:bodyPr>
+          <a:lstStyle/>
+          <a:p>
+            <a:pPr algn="ctr">
+              <a:lnSpc>
+                <a:spcPct val="110000"/>
+              </a:lnSpc>
+            </a:pPr>
+            <a:r>
+              <a:rPr sz="2000" b="1">
+                <a:solidFill>
+                  <a:srgbClr val="FFFFFF"/>
+                </a:solidFill>
+                <a:latin typeface="Arial"/>
+                <a:ea typeface="Arial"/>
+              </a:rPr>
+              <a:t>1</a:t>
+            </a:r>
+          </a:p>
+        </p:txBody>
+      </p:sp>
+      <p:sp>
+        <p:nvSpPr>
+          <p:cNvPr id="9" name="TextBox 8"/>
+          <p:cNvSpPr txBox="1"/>
+          <p:nvPr/>
+        </p:nvSpPr>
+        <p:spPr>
+          <a:xfrm>
+            <a:off x="1307592" y="2103120"/>
+            <a:ext cx="7424927" cy="512063"/>
+          </a:xfrm>
+          <a:prstGeom prst="rect">
+            <a:avLst/>
+          </a:prstGeom>
+          <a:noFill/>
+        </p:spPr>
+        <p:txBody>
+          <a:bodyPr wrap="square" anchor="ctr" lIns="0" rIns="0" tIns="0" bIns="0">
+            <a:spAutoFit/>
+          </a:bodyPr>
+          <a:lstStyle/>
+          <a:p>
+            <a:pPr algn="l">
+              <a:lnSpc>
+                <a:spcPct val="110000"/>
+              </a:lnSpc>
+            </a:pPr>
+            <a:r>
+              <a:rPr sz="2400" b="1">
+                <a:solidFill>
+                  <a:srgbClr val="1A1A1A"/>
+                </a:solidFill>
+                <a:latin typeface="Arial"/>
+                <a:ea typeface="Arial"/>
+              </a:rPr>
+              <a:t>위기: Shrink 장벽 · 후발 추격</a:t>
+            </a:r>
+          </a:p>
+        </p:txBody>
+      </p:sp>
+      <p:sp>
+        <p:nvSpPr>
+          <p:cNvPr id="10" name="Oval 9"/>
+          <p:cNvSpPr/>
+          <p:nvPr/>
+        </p:nvSpPr>
+        <p:spPr>
+          <a:xfrm>
+            <a:off x="9372600" y="2139696"/>
+            <a:ext cx="438912" cy="438912"/>
+          </a:xfrm>
+          <a:prstGeom prst="ellipse">
+            <a:avLst/>
+          </a:prstGeom>
+          <a:solidFill>
+            <a:srgbClr val="0E9384"/>
+          </a:solidFill>
+          <a:ln>
+            <a:noFill/>
+          </a:ln>
+          <a:effectLst/>
+        </p:spPr>
+        <p:style>
+          <a:lnRef idx="1">
+            <a:schemeClr val="accent1"/>
+          </a:lnRef>
+          <a:fillRef idx="3">
+            <a:schemeClr val="accent1"/>
+          </a:fillRef>
+          <a:effectRef idx="2">
+            <a:schemeClr val="accent1"/>
+          </a:effectRef>
+          <a:fontRef idx="minor">
+            <a:schemeClr val="lt1"/>
+          </a:fontRef>
+        </p:style>
+        <p:txBody>
+          <a:bodyPr rtlCol="0" anchor="ctr"/>
+          <a:lstStyle/>
+          <a:p>
+            <a:pPr algn="ctr"/>
+          </a:p>
+        </p:txBody>
+      </p:sp>
+      <p:sp>
+        <p:nvSpPr>
+          <p:cNvPr id="11" name="TextBox 10"/>
+          <p:cNvSpPr txBox="1"/>
+          <p:nvPr/>
+        </p:nvSpPr>
+        <p:spPr>
+          <a:xfrm>
+            <a:off x="9372600" y="2139696"/>
+            <a:ext cx="438912" cy="438912"/>
+          </a:xfrm>
+          <a:prstGeom prst="rect">
+            <a:avLst/>
+          </a:prstGeom>
+          <a:noFill/>
+        </p:spPr>
+        <p:txBody>
+          <a:bodyPr wrap="square" anchor="ctr" lIns="0" rIns="0" tIns="0" bIns="0">
+            <a:spAutoFit/>
+          </a:bodyPr>
+          <a:lstStyle/>
+          <a:p>
+            <a:pPr algn="ctr">
+              <a:lnSpc>
+                <a:spcPct val="110000"/>
+              </a:lnSpc>
+            </a:pPr>
+            <a:r>
+              <a:rPr sz="2000" b="1">
+                <a:solidFill>
+                  <a:srgbClr val="FFFFFF"/>
+                </a:solidFill>
+                <a:latin typeface="Arial"/>
+                <a:ea typeface="Arial"/>
+              </a:rPr>
+              <a:t>2</a:t>
+            </a:r>
+          </a:p>
+        </p:txBody>
+      </p:sp>
+      <p:sp>
+        <p:nvSpPr>
+          <p:cNvPr id="12" name="TextBox 11"/>
+          <p:cNvSpPr txBox="1"/>
+          <p:nvPr/>
+        </p:nvSpPr>
+        <p:spPr>
+          <a:xfrm>
+            <a:off x="9957816" y="2103120"/>
+            <a:ext cx="7607808" cy="512063"/>
+          </a:xfrm>
+          <a:prstGeom prst="rect">
+            <a:avLst/>
+          </a:prstGeom>
+          <a:noFill/>
+        </p:spPr>
+        <p:txBody>
+          <a:bodyPr wrap="square" anchor="ctr" lIns="0" rIns="0" tIns="0" bIns="0">
+            <a:spAutoFit/>
+          </a:bodyPr>
+          <a:lstStyle/>
+          <a:p>
+            <a:pPr algn="l">
+              <a:lnSpc>
+                <a:spcPct val="110000"/>
+              </a:lnSpc>
+            </a:pPr>
+            <a:r>
+              <a:rPr sz="2400" b="1">
+                <a:solidFill>
+                  <a:srgbClr val="1A1A1A"/>
+                </a:solidFill>
+                <a:latin typeface="Arial"/>
+                <a:ea typeface="Arial"/>
+              </a:rPr>
+              <a:t>기회: 추론의 병목은 메모리</a:t>
+            </a:r>
+          </a:p>
+        </p:txBody>
+      </p:sp>
+      <p:sp>
+        <p:nvSpPr>
+          <p:cNvPr id="13" name="Rectangle 12"/>
+          <p:cNvSpPr/>
+          <p:nvPr/>
+        </p:nvSpPr>
+        <p:spPr>
+          <a:xfrm>
+            <a:off x="722376" y="8778240"/>
+            <a:ext cx="16843248" cy="731520"/>
+          </a:xfrm>
+          <a:prstGeom prst="rect">
+            <a:avLst/>
+          </a:prstGeom>
+          <a:solidFill>
+            <a:srgbClr val="3C4FA5"/>
+          </a:solidFill>
+          <a:ln>
+            <a:noFill/>
+          </a:ln>
+          <a:effectLst/>
+        </p:spPr>
+        <p:style>
+          <a:lnRef idx="1">
+            <a:schemeClr val="accent1"/>
+          </a:lnRef>
+          <a:fillRef idx="3">
+            <a:schemeClr val="accent1"/>
+          </a:fillRef>
+          <a:effectRef idx="2">
+            <a:schemeClr val="accent1"/>
+          </a:effectRef>
+          <a:fontRef idx="minor">
+            <a:schemeClr val="lt1"/>
+          </a:fontRef>
+        </p:style>
+        <p:txBody>
+          <a:bodyPr rtlCol="0" anchor="ctr"/>
+          <a:lstStyle/>
+          <a:p>
+            <a:pPr algn="ctr"/>
+          </a:p>
+        </p:txBody>
+      </p:sp>
+      <p:sp>
+        <p:nvSpPr>
+          <p:cNvPr id="14" name="TextBox 13"/>
+          <p:cNvSpPr txBox="1"/>
+          <p:nvPr/>
+        </p:nvSpPr>
+        <p:spPr>
+          <a:xfrm>
+            <a:off x="1088136" y="8778240"/>
+            <a:ext cx="1234440" cy="731520"/>
+          </a:xfrm>
+          <a:prstGeom prst="rect">
+            <a:avLst/>
+          </a:prstGeom>
+          <a:noFill/>
+        </p:spPr>
+        <p:txBody>
+          <a:bodyPr wrap="square" anchor="ctr" lIns="0" rIns="0" tIns="0" bIns="0">
+            <a:spAutoFit/>
+          </a:bodyPr>
+          <a:lstStyle/>
+          <a:p>
+            <a:pPr algn="l">
+              <a:lnSpc>
+                <a:spcPct val="110000"/>
+              </a:lnSpc>
+            </a:pPr>
+            <a:r>
+              <a:rPr sz="2000" b="0">
+                <a:solidFill>
+                  <a:srgbClr val="C0CAEC"/>
+                </a:solidFill>
+                <a:latin typeface="Arial"/>
+                <a:ea typeface="Arial"/>
+              </a:rPr>
+              <a:t>현실</a:t>
+            </a:r>
+          </a:p>
+        </p:txBody>
+      </p:sp>
+      <p:sp>
+        <p:nvSpPr>
+          <p:cNvPr id="15" name="TextBox 14"/>
+          <p:cNvSpPr txBox="1"/>
+          <p:nvPr/>
+        </p:nvSpPr>
+        <p:spPr>
+          <a:xfrm>
+            <a:off x="2322576" y="8778240"/>
+            <a:ext cx="15060168" cy="731520"/>
+          </a:xfrm>
+          <a:prstGeom prst="rect">
+            <a:avLst/>
+          </a:prstGeom>
+          <a:noFill/>
+        </p:spPr>
+        <p:txBody>
+          <a:bodyPr wrap="square" anchor="ctr" lIns="0" rIns="0" tIns="0" bIns="0">
+            <a:spAutoFit/>
+          </a:bodyPr>
+          <a:lstStyle/>
+          <a:p>
+            <a:pPr algn="l">
+              <a:lnSpc>
+                <a:spcPct val="110000"/>
+              </a:lnSpc>
+            </a:pPr>
+            <a:r>
+              <a:rPr sz="2400" b="1">
+                <a:solidFill>
+                  <a:srgbClr val="FFFFFF"/>
+                </a:solidFill>
+                <a:latin typeface="Arial"/>
+                <a:ea typeface="Arial"/>
+              </a:rPr>
+              <a:t>Shrink만으로는 격차를 지킬 수 없다. 차별화는 AI 추론의 메모리 병목에서 찾는다</a:t>
+            </a:r>
+          </a:p>
+        </p:txBody>
+      </p:sp>
+      <p:pic>
+        <p:nvPicPr>
+          <p:cNvPr id="16" name="Picture 15" descr="node_simple_log.png"/>
+          <p:cNvPicPr>
+            <a:picLocks noChangeAspect="1"/>
+          </p:cNvPicPr>
+          <p:nvPr/>
+        </p:nvPicPr>
+        <p:blipFill>
+          <a:blip r:embed="rId2"/>
+          <a:stretch>
+            <a:fillRect/>
+          </a:stretch>
+        </p:blipFill>
+        <p:spPr>
+          <a:xfrm>
+            <a:off x="722376" y="2724912"/>
+            <a:ext cx="8010144" cy="5852160"/>
+          </a:xfrm>
+          <a:prstGeom prst="rect">
+            <a:avLst/>
+          </a:prstGeom>
+        </p:spPr>
+      </p:pic>
+      <p:pic>
+        <p:nvPicPr>
+          <p:cNvPr id="17" name="Picture 16" descr="drivers_big.png"/>
+          <p:cNvPicPr>
+            <a:picLocks noChangeAspect="1"/>
+          </p:cNvPicPr>
+          <p:nvPr/>
+        </p:nvPicPr>
+        <p:blipFill>
+          <a:blip r:embed="rId3"/>
+          <a:stretch>
+            <a:fillRect/>
+          </a:stretch>
+        </p:blipFill>
+        <p:spPr>
+          <a:xfrm>
+            <a:off x="9372600" y="2724912"/>
+            <a:ext cx="8193024" cy="2468880"/>
+          </a:xfrm>
+          <a:prstGeom prst="rect">
+            <a:avLst/>
+          </a:prstGeom>
+        </p:spPr>
+      </p:pic>
+      <p:sp>
+        <p:nvSpPr>
+          <p:cNvPr id="18" name="Rounded Rectangle 17"/>
+          <p:cNvSpPr/>
+          <p:nvPr/>
+        </p:nvSpPr>
+        <p:spPr>
+          <a:xfrm>
+            <a:off x="9372600" y="5358384"/>
+            <a:ext cx="2331720" cy="1188720"/>
+          </a:xfrm>
+          <a:prstGeom prst="roundRect">
+            <a:avLst>
+              <a:gd name="adj" fmla="val 6153"/>
+            </a:avLst>
+          </a:prstGeom>
+          <a:solidFill>
+            <a:srgbClr val="F0EBFA"/>
+          </a:solidFill>
+          <a:ln w="15875">
+            <a:solidFill>
+              <a:srgbClr val="6941C6"/>
+            </a:solidFill>
+          </a:ln>
+          <a:effectLst/>
+        </p:spPr>
+        <p:style>
+          <a:lnRef idx="1">
+            <a:schemeClr val="accent1"/>
+          </a:lnRef>
+          <a:fillRef idx="3">
+            <a:schemeClr val="accent1"/>
+          </a:fillRef>
+          <a:effectRef idx="2">
+            <a:schemeClr val="accent1"/>
+          </a:effectRef>
+          <a:fontRef idx="minor">
+            <a:schemeClr val="lt1"/>
+          </a:fontRef>
+        </p:style>
+        <p:txBody>
+          <a:bodyPr rtlCol="0" anchor="ctr"/>
+          <a:lstStyle/>
+          <a:p>
+            <a:pPr algn="ctr"/>
+          </a:p>
+        </p:txBody>
+      </p:sp>
+      <p:sp>
+        <p:nvSpPr>
+          <p:cNvPr id="19" name="TextBox 18"/>
+          <p:cNvSpPr txBox="1"/>
+          <p:nvPr/>
+        </p:nvSpPr>
+        <p:spPr>
+          <a:xfrm>
+            <a:off x="9372600" y="5431536"/>
+            <a:ext cx="2331720" cy="658368"/>
+          </a:xfrm>
+          <a:prstGeom prst="rect">
+            <a:avLst/>
+          </a:prstGeom>
+          <a:noFill/>
+        </p:spPr>
+        <p:txBody>
+          <a:bodyPr wrap="square" anchor="ctr" lIns="0" rIns="0" tIns="0" bIns="0">
+            <a:spAutoFit/>
+          </a:bodyPr>
+          <a:lstStyle/>
+          <a:p>
+            <a:pPr algn="ctr">
+              <a:lnSpc>
+                <a:spcPct val="110000"/>
+              </a:lnSpc>
+            </a:pPr>
+            <a:r>
+              <a:rPr sz="3400" b="1">
+                <a:solidFill>
+                  <a:srgbClr val="6941C6"/>
+                </a:solidFill>
+                <a:latin typeface="Arial"/>
+                <a:ea typeface="Arial"/>
+              </a:rPr>
+              <a:t>320 KiB</a:t>
+            </a:r>
+          </a:p>
+        </p:txBody>
+      </p:sp>
+      <p:sp>
+        <p:nvSpPr>
+          <p:cNvPr id="20" name="TextBox 19"/>
+          <p:cNvSpPr txBox="1"/>
+          <p:nvPr/>
+        </p:nvSpPr>
+        <p:spPr>
+          <a:xfrm>
+            <a:off x="9372600" y="6108192"/>
+            <a:ext cx="2331720" cy="329184"/>
+          </a:xfrm>
+          <a:prstGeom prst="rect">
+            <a:avLst/>
+          </a:prstGeom>
+          <a:noFill/>
+        </p:spPr>
+        <p:txBody>
+          <a:bodyPr wrap="square" anchor="ctr" lIns="0" rIns="0" tIns="0" bIns="0">
+            <a:spAutoFit/>
+          </a:bodyPr>
+          <a:lstStyle/>
+          <a:p>
+            <a:pPr algn="ctr">
+              <a:lnSpc>
+                <a:spcPct val="110000"/>
+              </a:lnSpc>
+            </a:pPr>
+            <a:r>
+              <a:rPr sz="1800" b="0">
+                <a:solidFill>
+                  <a:srgbClr val="1A1A1A"/>
+                </a:solidFill>
+                <a:latin typeface="Arial"/>
+                <a:ea typeface="Arial"/>
+              </a:rPr>
+              <a:t>KV / 토큰</a:t>
+            </a:r>
+          </a:p>
+        </p:txBody>
+      </p:sp>
+      <p:sp>
+        <p:nvSpPr>
+          <p:cNvPr id="21" name="TextBox 20"/>
+          <p:cNvSpPr txBox="1"/>
+          <p:nvPr/>
+        </p:nvSpPr>
+        <p:spPr>
+          <a:xfrm>
+            <a:off x="11704320" y="5358384"/>
+            <a:ext cx="457200" cy="1188720"/>
+          </a:xfrm>
+          <a:prstGeom prst="rect">
+            <a:avLst/>
+          </a:prstGeom>
+          <a:noFill/>
+        </p:spPr>
+        <p:txBody>
+          <a:bodyPr wrap="square" anchor="ctr" lIns="0" rIns="0" tIns="0" bIns="0">
+            <a:spAutoFit/>
+          </a:bodyPr>
+          <a:lstStyle/>
+          <a:p>
+            <a:pPr algn="ctr">
+              <a:lnSpc>
+                <a:spcPct val="110000"/>
+              </a:lnSpc>
+            </a:pPr>
+            <a:r>
+              <a:rPr sz="3600" b="1">
+                <a:solidFill>
+                  <a:srgbClr val="555555"/>
+                </a:solidFill>
+                <a:latin typeface="Arial"/>
+                <a:ea typeface="Arial"/>
+              </a:rPr>
+              <a:t>×</a:t>
+            </a:r>
+          </a:p>
+        </p:txBody>
+      </p:sp>
+      <p:sp>
+        <p:nvSpPr>
+          <p:cNvPr id="22" name="Rounded Rectangle 21"/>
+          <p:cNvSpPr/>
+          <p:nvPr/>
+        </p:nvSpPr>
+        <p:spPr>
+          <a:xfrm>
+            <a:off x="12161520" y="5358384"/>
+            <a:ext cx="2331720" cy="1188720"/>
+          </a:xfrm>
+          <a:prstGeom prst="roundRect">
+            <a:avLst>
+              <a:gd name="adj" fmla="val 6153"/>
+            </a:avLst>
+          </a:prstGeom>
+          <a:solidFill>
+            <a:srgbClr val="E6F3F1"/>
+          </a:solidFill>
+          <a:ln w="15875">
+            <a:solidFill>
+              <a:srgbClr val="0E9384"/>
+            </a:solidFill>
+          </a:ln>
+          <a:effectLst/>
+        </p:spPr>
+        <p:style>
+          <a:lnRef idx="1">
+            <a:schemeClr val="accent1"/>
+          </a:lnRef>
+          <a:fillRef idx="3">
+            <a:schemeClr val="accent1"/>
+          </a:fillRef>
+          <a:effectRef idx="2">
+            <a:schemeClr val="accent1"/>
+          </a:effectRef>
+          <a:fontRef idx="minor">
+            <a:schemeClr val="lt1"/>
+          </a:fontRef>
+        </p:style>
+        <p:txBody>
+          <a:bodyPr rtlCol="0" anchor="ctr"/>
+          <a:lstStyle/>
+          <a:p>
+            <a:pPr algn="ctr"/>
+          </a:p>
+        </p:txBody>
+      </p:sp>
+      <p:sp>
+        <p:nvSpPr>
+          <p:cNvPr id="23" name="TextBox 22"/>
+          <p:cNvSpPr txBox="1"/>
+          <p:nvPr/>
+        </p:nvSpPr>
+        <p:spPr>
+          <a:xfrm>
+            <a:off x="12161520" y="5431536"/>
+            <a:ext cx="2331720" cy="658368"/>
+          </a:xfrm>
+          <a:prstGeom prst="rect">
+            <a:avLst/>
+          </a:prstGeom>
+          <a:noFill/>
+        </p:spPr>
+        <p:txBody>
+          <a:bodyPr wrap="square" anchor="ctr" lIns="0" rIns="0" tIns="0" bIns="0">
+            <a:spAutoFit/>
+          </a:bodyPr>
+          <a:lstStyle/>
+          <a:p>
+            <a:pPr algn="ctr">
+              <a:lnSpc>
+                <a:spcPct val="110000"/>
+              </a:lnSpc>
+            </a:pPr>
+            <a:r>
+              <a:rPr sz="3400" b="1">
+                <a:solidFill>
+                  <a:srgbClr val="0E9384"/>
+                </a:solidFill>
+                <a:latin typeface="Arial"/>
+                <a:ea typeface="Arial"/>
+              </a:rPr>
+              <a:t>3,200조</a:t>
+            </a:r>
+          </a:p>
+        </p:txBody>
+      </p:sp>
+      <p:sp>
+        <p:nvSpPr>
+          <p:cNvPr id="24" name="TextBox 23"/>
+          <p:cNvSpPr txBox="1"/>
+          <p:nvPr/>
+        </p:nvSpPr>
+        <p:spPr>
+          <a:xfrm>
+            <a:off x="12161520" y="6108192"/>
+            <a:ext cx="2331720" cy="329184"/>
+          </a:xfrm>
+          <a:prstGeom prst="rect">
+            <a:avLst/>
+          </a:prstGeom>
+          <a:noFill/>
+        </p:spPr>
+        <p:txBody>
+          <a:bodyPr wrap="square" anchor="ctr" lIns="0" rIns="0" tIns="0" bIns="0">
+            <a:spAutoFit/>
+          </a:bodyPr>
+          <a:lstStyle/>
+          <a:p>
+            <a:pPr algn="ctr">
+              <a:lnSpc>
+                <a:spcPct val="110000"/>
+              </a:lnSpc>
+            </a:pPr>
+            <a:r>
+              <a:rPr sz="1800" b="0">
+                <a:solidFill>
+                  <a:srgbClr val="1A1A1A"/>
+                </a:solidFill>
+                <a:latin typeface="Arial"/>
+                <a:ea typeface="Arial"/>
+              </a:rPr>
+              <a:t>월간 토큰</a:t>
+            </a:r>
+          </a:p>
+        </p:txBody>
+      </p:sp>
+      <p:sp>
+        <p:nvSpPr>
+          <p:cNvPr id="25" name="TextBox 24"/>
+          <p:cNvSpPr txBox="1"/>
+          <p:nvPr/>
+        </p:nvSpPr>
+        <p:spPr>
+          <a:xfrm>
+            <a:off x="14493240" y="5358384"/>
+            <a:ext cx="457200" cy="1188720"/>
+          </a:xfrm>
+          <a:prstGeom prst="rect">
+            <a:avLst/>
+          </a:prstGeom>
+          <a:noFill/>
+        </p:spPr>
+        <p:txBody>
+          <a:bodyPr wrap="square" anchor="ctr" lIns="0" rIns="0" tIns="0" bIns="0">
+            <a:spAutoFit/>
+          </a:bodyPr>
+          <a:lstStyle/>
+          <a:p>
+            <a:pPr algn="ctr">
+              <a:lnSpc>
+                <a:spcPct val="110000"/>
+              </a:lnSpc>
+            </a:pPr>
+            <a:r>
+              <a:rPr sz="3600" b="1">
+                <a:solidFill>
+                  <a:srgbClr val="555555"/>
+                </a:solidFill>
+                <a:latin typeface="Arial"/>
+                <a:ea typeface="Arial"/>
+              </a:rPr>
+              <a:t>=</a:t>
+            </a:r>
+          </a:p>
+        </p:txBody>
+      </p:sp>
+      <p:sp>
+        <p:nvSpPr>
+          <p:cNvPr id="26" name="Rounded Rectangle 25"/>
+          <p:cNvSpPr/>
+          <p:nvPr/>
+        </p:nvSpPr>
+        <p:spPr>
+          <a:xfrm>
+            <a:off x="14950440" y="5358384"/>
+            <a:ext cx="2615184" cy="1188720"/>
+          </a:xfrm>
+          <a:prstGeom prst="roundRect">
+            <a:avLst>
+              <a:gd name="adj" fmla="val 6153"/>
+            </a:avLst>
+          </a:prstGeom>
+          <a:solidFill>
+            <a:srgbClr val="E8590C"/>
+          </a:solidFill>
+          <a:ln w="15875">
+            <a:solidFill>
+              <a:srgbClr val="E8590C"/>
+            </a:solidFill>
+          </a:ln>
+          <a:effectLst/>
+        </p:spPr>
+        <p:style>
+          <a:lnRef idx="1">
+            <a:schemeClr val="accent1"/>
+          </a:lnRef>
+          <a:fillRef idx="3">
+            <a:schemeClr val="accent1"/>
+          </a:fillRef>
+          <a:effectRef idx="2">
+            <a:schemeClr val="accent1"/>
+          </a:effectRef>
+          <a:fontRef idx="minor">
+            <a:schemeClr val="lt1"/>
+          </a:fontRef>
+        </p:style>
+        <p:txBody>
+          <a:bodyPr rtlCol="0" anchor="ctr"/>
+          <a:lstStyle/>
+          <a:p>
+            <a:pPr algn="ctr"/>
+          </a:p>
+        </p:txBody>
+      </p:sp>
+      <p:sp>
+        <p:nvSpPr>
+          <p:cNvPr id="27" name="TextBox 26"/>
+          <p:cNvSpPr txBox="1"/>
+          <p:nvPr/>
+        </p:nvSpPr>
+        <p:spPr>
+          <a:xfrm>
+            <a:off x="14950440" y="5431536"/>
+            <a:ext cx="2615184" cy="658368"/>
+          </a:xfrm>
+          <a:prstGeom prst="rect">
+            <a:avLst/>
+          </a:prstGeom>
+          <a:noFill/>
+        </p:spPr>
+        <p:txBody>
+          <a:bodyPr wrap="square" anchor="ctr" lIns="0" rIns="0" tIns="0" bIns="0">
+            <a:spAutoFit/>
+          </a:bodyPr>
+          <a:lstStyle/>
+          <a:p>
+            <a:pPr algn="ctr">
+              <a:lnSpc>
+                <a:spcPct val="110000"/>
+              </a:lnSpc>
+            </a:pPr>
+            <a:r>
+              <a:rPr sz="3400" b="1">
+                <a:solidFill>
+                  <a:srgbClr val="FFFFFF"/>
+                </a:solidFill>
+                <a:latin typeface="Arial"/>
+                <a:ea typeface="Arial"/>
+              </a:rPr>
+              <a:t>월 1 ZB</a:t>
+            </a:r>
+          </a:p>
+        </p:txBody>
+      </p:sp>
+      <p:sp>
+        <p:nvSpPr>
+          <p:cNvPr id="28" name="TextBox 27"/>
+          <p:cNvSpPr txBox="1"/>
+          <p:nvPr/>
+        </p:nvSpPr>
+        <p:spPr>
+          <a:xfrm>
+            <a:off x="14950440" y="6108192"/>
+            <a:ext cx="2615184" cy="329184"/>
+          </a:xfrm>
+          <a:prstGeom prst="rect">
+            <a:avLst/>
+          </a:prstGeom>
+          <a:noFill/>
+        </p:spPr>
+        <p:txBody>
+          <a:bodyPr wrap="square" anchor="ctr" lIns="0" rIns="0" tIns="0" bIns="0">
+            <a:spAutoFit/>
+          </a:bodyPr>
+          <a:lstStyle/>
+          <a:p>
+            <a:pPr algn="ctr">
+              <a:lnSpc>
+                <a:spcPct val="110000"/>
+              </a:lnSpc>
+            </a:pPr>
+            <a:r>
+              <a:rPr sz="1800" b="0">
+                <a:solidFill>
+                  <a:srgbClr val="FFFFFF"/>
+                </a:solidFill>
+                <a:latin typeface="Arial"/>
+                <a:ea typeface="Arial"/>
+              </a:rPr>
+              <a:t>KV 생성</a:t>
+            </a:r>
+          </a:p>
+        </p:txBody>
+      </p:sp>
+      <p:sp>
+        <p:nvSpPr>
+          <p:cNvPr id="29" name="TextBox 28"/>
+          <p:cNvSpPr txBox="1"/>
+          <p:nvPr/>
+        </p:nvSpPr>
+        <p:spPr>
+          <a:xfrm>
+            <a:off x="9372600" y="6620256"/>
+            <a:ext cx="5394960" cy="274320"/>
+          </a:xfrm>
+          <a:prstGeom prst="rect">
+            <a:avLst/>
+          </a:prstGeom>
+          <a:noFill/>
+        </p:spPr>
+        <p:txBody>
+          <a:bodyPr wrap="square" anchor="ctr" lIns="0" rIns="0" tIns="0" bIns="0">
+            <a:spAutoFit/>
+          </a:bodyPr>
+          <a:lstStyle/>
+          <a:p>
+            <a:pPr algn="l">
+              <a:lnSpc>
+                <a:spcPct val="110000"/>
+              </a:lnSpc>
+            </a:pPr>
+            <a:r>
+              <a:rPr sz="1500" b="0">
+                <a:solidFill>
+                  <a:srgbClr val="555555"/>
+                </a:solidFill>
+                <a:latin typeface="Arial"/>
+                <a:ea typeface="Arial"/>
+              </a:rPr>
+              <a:t>토큰당 KV 절감(70B, MHA → GQA · FP4) vs 토큰 증가(2년)</a:t>
+            </a:r>
+          </a:p>
+        </p:txBody>
+      </p:sp>
+      <p:pic>
+        <p:nvPicPr>
+          <p:cNvPr id="30" name="Picture 29" descr="tug2_small.png"/>
+          <p:cNvPicPr>
+            <a:picLocks noChangeAspect="1"/>
+          </p:cNvPicPr>
+          <p:nvPr/>
+        </p:nvPicPr>
+        <p:blipFill>
+          <a:blip r:embed="rId4"/>
+          <a:stretch>
+            <a:fillRect/>
+          </a:stretch>
+        </p:blipFill>
+        <p:spPr>
+          <a:xfrm>
+            <a:off x="9372600" y="6858000"/>
+            <a:ext cx="5394959" cy="1737360"/>
+          </a:xfrm>
+          <a:prstGeom prst="rect">
+            <a:avLst/>
+          </a:prstGeom>
+        </p:spPr>
+      </p:pic>
+      <p:sp>
+        <p:nvSpPr>
+          <p:cNvPr id="31" name="Rounded Rectangle 30"/>
+          <p:cNvSpPr/>
+          <p:nvPr/>
+        </p:nvSpPr>
+        <p:spPr>
+          <a:xfrm>
+            <a:off x="15005304" y="6784848"/>
+            <a:ext cx="2560320" cy="1755648"/>
+          </a:xfrm>
+          <a:prstGeom prst="roundRect">
+            <a:avLst>
+              <a:gd name="adj" fmla="val 4166"/>
+            </a:avLst>
+          </a:prstGeom>
+          <a:solidFill>
+            <a:srgbClr val="FFFFFF"/>
+          </a:solidFill>
+          <a:ln w="19050">
+            <a:solidFill>
+              <a:srgbClr val="D93025"/>
+            </a:solidFill>
+          </a:ln>
+          <a:effectLst/>
+        </p:spPr>
+        <p:style>
+          <a:lnRef idx="1">
+            <a:schemeClr val="accent1"/>
+          </a:lnRef>
+          <a:fillRef idx="3">
+            <a:schemeClr val="accent1"/>
+          </a:fillRef>
+          <a:effectRef idx="2">
+            <a:schemeClr val="accent1"/>
+          </a:effectRef>
+          <a:fontRef idx="minor">
+            <a:schemeClr val="lt1"/>
+          </a:fontRef>
+        </p:style>
+        <p:txBody>
+          <a:bodyPr rtlCol="0" anchor="ctr"/>
+          <a:lstStyle/>
+          <a:p>
+            <a:pPr algn="ctr"/>
+          </a:p>
+        </p:txBody>
+      </p:sp>
+      <p:sp>
+        <p:nvSpPr>
+          <p:cNvPr id="32" name="TextBox 31"/>
+          <p:cNvSpPr txBox="1"/>
+          <p:nvPr/>
+        </p:nvSpPr>
+        <p:spPr>
+          <a:xfrm>
+            <a:off x="15005304" y="6876288"/>
+            <a:ext cx="2560320" cy="310896"/>
+          </a:xfrm>
+          <a:prstGeom prst="rect">
+            <a:avLst/>
+          </a:prstGeom>
+          <a:noFill/>
+        </p:spPr>
+        <p:txBody>
+          <a:bodyPr wrap="square" anchor="ctr" lIns="0" rIns="0" tIns="0" bIns="0">
+            <a:spAutoFit/>
+          </a:bodyPr>
+          <a:lstStyle/>
+          <a:p>
+            <a:pPr algn="ctr">
+              <a:lnSpc>
+                <a:spcPct val="110000"/>
+              </a:lnSpc>
+            </a:pPr>
+            <a:r>
+              <a:rPr sz="1800" b="1">
+                <a:solidFill>
+                  <a:srgbClr val="1A1A1A"/>
+                </a:solidFill>
+                <a:latin typeface="Arial"/>
+                <a:ea typeface="Arial"/>
+              </a:rPr>
+              <a:t>메모리 공급</a:t>
+            </a:r>
+          </a:p>
+        </p:txBody>
+      </p:sp>
+      <p:sp>
+        <p:nvSpPr>
+          <p:cNvPr id="33" name="TextBox 32"/>
+          <p:cNvSpPr txBox="1"/>
+          <p:nvPr/>
+        </p:nvSpPr>
+        <p:spPr>
+          <a:xfrm>
+            <a:off x="15005304" y="7205472"/>
+            <a:ext cx="2560320" cy="731520"/>
+          </a:xfrm>
+          <a:prstGeom prst="rect">
+            <a:avLst/>
+          </a:prstGeom>
+          <a:noFill/>
+        </p:spPr>
+        <p:txBody>
+          <a:bodyPr wrap="square" anchor="ctr" lIns="0" rIns="0" tIns="0" bIns="0">
+            <a:spAutoFit/>
+          </a:bodyPr>
+          <a:lstStyle/>
+          <a:p>
+            <a:pPr algn="ctr">
+              <a:lnSpc>
+                <a:spcPct val="110000"/>
+              </a:lnSpc>
+            </a:pPr>
+            <a:r>
+              <a:rPr sz="4800" b="1">
+                <a:solidFill>
+                  <a:srgbClr val="D93025"/>
+                </a:solidFill>
+                <a:latin typeface="Arial"/>
+                <a:ea typeface="Arial"/>
+              </a:rPr>
+              <a:t>2028</a:t>
+            </a:r>
+          </a:p>
+        </p:txBody>
+      </p:sp>
+      <p:sp>
+        <p:nvSpPr>
+          <p:cNvPr id="34" name="TextBox 33"/>
+          <p:cNvSpPr txBox="1"/>
+          <p:nvPr/>
+        </p:nvSpPr>
+        <p:spPr>
+          <a:xfrm>
+            <a:off x="15005304" y="8138160"/>
+            <a:ext cx="2560320" cy="310896"/>
+          </a:xfrm>
+          <a:prstGeom prst="rect">
+            <a:avLst/>
+          </a:prstGeom>
+          <a:noFill/>
+        </p:spPr>
+        <p:txBody>
+          <a:bodyPr wrap="square" anchor="ctr" lIns="0" rIns="0" tIns="0" bIns="0">
+            <a:spAutoFit/>
+          </a:bodyPr>
+          <a:lstStyle/>
+          <a:p>
+            <a:pPr algn="ctr">
+              <a:lnSpc>
+                <a:spcPct val="110000"/>
+              </a:lnSpc>
+            </a:pPr>
+            <a:r>
+              <a:rPr sz="1600" b="0">
+                <a:solidFill>
+                  <a:srgbClr val="555555"/>
+                </a:solidFill>
+                <a:latin typeface="Arial"/>
+                <a:ea typeface="Arial"/>
+              </a:rPr>
+              <a:t>신규 팹 실질 출하</a:t>
+            </a:r>
+          </a:p>
+        </p:txBody>
+      </p:sp>
+      <p:sp>
+        <p:nvSpPr>
+          <p:cNvPr id="35" name="TextBox 34"/>
+          <p:cNvSpPr txBox="1"/>
+          <p:nvPr/>
+        </p:nvSpPr>
+        <p:spPr>
+          <a:xfrm>
+            <a:off x="722376" y="9601200"/>
+            <a:ext cx="15453359" cy="310896"/>
+          </a:xfrm>
+          <a:prstGeom prst="rect">
+            <a:avLst/>
+          </a:prstGeom>
+          <a:noFill/>
+        </p:spPr>
+        <p:txBody>
+          <a:bodyPr wrap="square" anchor="t" lIns="0" rIns="0" tIns="0" bIns="0">
+            <a:spAutoFit/>
+          </a:bodyPr>
+          <a:lstStyle/>
+          <a:p>
+            <a:pPr algn="l">
+              <a:lnSpc>
+                <a:spcPct val="110000"/>
+              </a:lnSpc>
+            </a:pPr>
+            <a:r>
+              <a:rPr sz="1500" b="0">
+                <a:solidFill>
+                  <a:srgbClr val="555555"/>
+                </a:solidFill>
+                <a:latin typeface="Arial"/>
+                <a:ea typeface="Arial"/>
+              </a:rPr>
+              <a:t>출처: ITRS · TechInsights · Fab Tracker Q2'26 · Digitimes / Llama 3.1 설정 산식 · Google I/O · TrendForce 2026-07 · 산술은 가정 의존 · 부품은 3D 렌더 · 상세 근거는 시안 A~C</a:t>
+            </a:r>
+          </a:p>
+        </p:txBody>
+      </p:sp>
+      <p:sp>
+        <p:nvSpPr>
+          <p:cNvPr id="36" name="TextBox 35"/>
+          <p:cNvSpPr txBox="1"/>
+          <p:nvPr/>
+        </p:nvSpPr>
+        <p:spPr>
+          <a:xfrm>
+            <a:off x="16102584" y="9601200"/>
+            <a:ext cx="1463040" cy="310896"/>
+          </a:xfrm>
+          <a:prstGeom prst="rect">
+            <a:avLst/>
+          </a:prstGeom>
+          <a:noFill/>
+        </p:spPr>
+        <p:txBody>
+          <a:bodyPr wrap="square" anchor="t" lIns="0" rIns="0" tIns="0" bIns="0">
+            <a:spAutoFit/>
+          </a:bodyPr>
+          <a:lstStyle/>
+          <a:p>
+            <a:pPr algn="r">
+              <a:lnSpc>
+                <a:spcPct val="110000"/>
+              </a:lnSpc>
+            </a:pPr>
+            <a:r>
+              <a:rPr sz="1600" b="1">
+                <a:solidFill>
+                  <a:srgbClr val="555555"/>
+                </a:solidFill>
+                <a:latin typeface="Arial"/>
+                <a:ea typeface="Arial"/>
+              </a:rPr>
+              <a:t>시안 A2</a:t>
+            </a:r>
+          </a:p>
+        </p:txBody>
+      </p:sp>
+    </p:spTree>
+  </p:cSld>
+  <p:clrMapOvr>
+    <a:masterClrMapping/>
+  </p:clrMapOvr>
+</p:sld>
+</file>
+
+<file path=ppt/slides/slide5.xml><?xml version="1.0" encoding="utf-8"?>
+<p:sld xmlns:a="http://schemas.openxmlformats.org/drawingml/2006/main" xmlns:p="http://schemas.openxmlformats.org/presentationml/2006/main" xmlns:r="http://schemas.openxmlformats.org/officeDocument/2006/relationships">
+  <p:cSld>
+    <p:spTree>
+      <p:nvGrpSpPr>
+        <p:cNvPr id="1" name=""/>
+        <p:cNvGrpSpPr/>
+        <p:nvPr/>
+      </p:nvGrpSpPr>
+      <p:grpSpPr/>
+      <p:sp>
+        <p:nvSpPr>
+          <p:cNvPr id="2" name="TextBox 1"/>
+          <p:cNvSpPr txBox="1"/>
+          <p:nvPr/>
+        </p:nvSpPr>
+        <p:spPr>
+          <a:xfrm>
+            <a:off x="722376" y="365760"/>
+            <a:ext cx="10972800" cy="329184"/>
+          </a:xfrm>
+          <a:prstGeom prst="rect">
+            <a:avLst/>
+          </a:prstGeom>
+          <a:noFill/>
+        </p:spPr>
+        <p:txBody>
+          <a:bodyPr wrap="square" anchor="t" lIns="0" rIns="0" tIns="0" bIns="0">
+            <a:spAutoFit/>
+          </a:bodyPr>
+          <a:lstStyle/>
+          <a:p>
+            <a:pPr algn="l">
+              <a:lnSpc>
+                <a:spcPct val="110000"/>
+              </a:lnSpc>
+            </a:pPr>
+            <a:r>
+              <a:rPr sz="1800" b="1">
+                <a:solidFill>
+                  <a:srgbClr val="3C4FA5"/>
+                </a:solidFill>
+                <a:latin typeface="Arial"/>
+                <a:ea typeface="Arial"/>
+              </a:rPr>
+              <a:t>DRAM 기술 경쟁력 제고 · 차별화 준비</a:t>
+            </a:r>
+            <a:r>
+              <a:rPr sz="1800" b="0">
+                <a:solidFill>
+                  <a:srgbClr val="555555"/>
+                </a:solidFill>
+                <a:latin typeface="Arial"/>
+                <a:ea typeface="Arial"/>
+              </a:rPr>
+              <a:t>   5 / 6  현실 파악 · 시안 B2 선순환형 간결</a:t>
+            </a:r>
+          </a:p>
+        </p:txBody>
+      </p:sp>
+      <p:sp>
+        <p:nvSpPr>
+          <p:cNvPr id="3" name="TextBox 2"/>
+          <p:cNvSpPr txBox="1"/>
+          <p:nvPr/>
+        </p:nvSpPr>
+        <p:spPr>
+          <a:xfrm>
+            <a:off x="12079224" y="365760"/>
+            <a:ext cx="5486400" cy="329184"/>
+          </a:xfrm>
+          <a:prstGeom prst="rect">
+            <a:avLst/>
+          </a:prstGeom>
+          <a:noFill/>
+        </p:spPr>
+        <p:txBody>
+          <a:bodyPr wrap="square" anchor="t" lIns="0" rIns="0" tIns="0" bIns="0">
+            <a:spAutoFit/>
+          </a:bodyPr>
+          <a:lstStyle/>
+          <a:p>
+            <a:pPr algn="r">
+              <a:lnSpc>
+                <a:spcPct val="110000"/>
+              </a:lnSpc>
+            </a:pPr>
+            <a:r>
+              <a:rPr sz="1800" b="0">
+                <a:solidFill>
+                  <a:srgbClr val="555555"/>
+                </a:solidFill>
+                <a:latin typeface="Arial"/>
+                <a:ea typeface="Arial"/>
+              </a:rPr>
+              <a:t>[문서등급 표기]</a:t>
+            </a:r>
+          </a:p>
+        </p:txBody>
+      </p:sp>
+      <p:sp>
+        <p:nvSpPr>
+          <p:cNvPr id="4" name="TextBox 3"/>
+          <p:cNvSpPr txBox="1"/>
+          <p:nvPr/>
+        </p:nvSpPr>
+        <p:spPr>
+          <a:xfrm>
+            <a:off x="722376" y="786384"/>
+            <a:ext cx="16843248" cy="1024128"/>
+          </a:xfrm>
+          <a:prstGeom prst="rect">
+            <a:avLst/>
+          </a:prstGeom>
+          <a:noFill/>
+        </p:spPr>
+        <p:txBody>
+          <a:bodyPr wrap="square" anchor="ctr" lIns="0" rIns="0" tIns="0" bIns="0">
+            <a:spAutoFit/>
+          </a:bodyPr>
+          <a:lstStyle/>
+          <a:p>
+            <a:pPr algn="l">
+              <a:lnSpc>
+                <a:spcPct val="105000"/>
+              </a:lnSpc>
+            </a:pPr>
+            <a:r>
+              <a:rPr sz="3200" b="1">
+                <a:solidFill>
+                  <a:srgbClr val="1A1A1A"/>
+                </a:solidFill>
+                <a:latin typeface="Arial"/>
+                <a:ea typeface="Arial"/>
+              </a:rPr>
+              <a:t>DRAM은 Shrink 장벽에 막혀 후발 주자의 추격을 받고 있지만,</a:t>
+            </a:r>
+          </a:p>
+          <a:p>
+            <a:pPr algn="l">
+              <a:lnSpc>
+                <a:spcPct val="105000"/>
+              </a:lnSpc>
+            </a:pPr>
+            <a:r>
+              <a:rPr sz="3200" b="1">
+                <a:solidFill>
+                  <a:srgbClr val="1A1A1A"/>
+                </a:solidFill>
+                <a:latin typeface="Arial"/>
+                <a:ea typeface="Arial"/>
+              </a:rPr>
+              <a:t>AI 추론의 병목이 연산에서 메모리로 옮겨 오며 차별화의 기회가 열리고 있다</a:t>
+            </a:r>
+          </a:p>
+        </p:txBody>
+      </p:sp>
+      <p:sp>
+        <p:nvSpPr>
+          <p:cNvPr id="5" name="Rectangle 4"/>
+          <p:cNvSpPr/>
+          <p:nvPr/>
+        </p:nvSpPr>
+        <p:spPr>
+          <a:xfrm>
+            <a:off x="722376" y="1938528"/>
+            <a:ext cx="16843248" cy="18288"/>
+          </a:xfrm>
+          <a:prstGeom prst="rect">
+            <a:avLst/>
+          </a:prstGeom>
+          <a:solidFill>
+            <a:srgbClr val="D9D9D9"/>
+          </a:solidFill>
+          <a:ln>
+            <a:noFill/>
+          </a:ln>
+          <a:effectLst/>
+        </p:spPr>
+        <p:style>
+          <a:lnRef idx="1">
+            <a:schemeClr val="accent1"/>
+          </a:lnRef>
+          <a:fillRef idx="3">
+            <a:schemeClr val="accent1"/>
+          </a:fillRef>
+          <a:effectRef idx="2">
+            <a:schemeClr val="accent1"/>
+          </a:effectRef>
+          <a:fontRef idx="minor">
+            <a:schemeClr val="lt1"/>
+          </a:fontRef>
+        </p:style>
+        <p:txBody>
+          <a:bodyPr rtlCol="0" anchor="ctr"/>
+          <a:lstStyle/>
+          <a:p>
+            <a:pPr algn="ctr"/>
+          </a:p>
+        </p:txBody>
+      </p:sp>
+      <p:sp>
+        <p:nvSpPr>
+          <p:cNvPr id="6" name="Rectangle 5"/>
+          <p:cNvSpPr/>
+          <p:nvPr/>
+        </p:nvSpPr>
+        <p:spPr>
+          <a:xfrm>
+            <a:off x="9015984" y="2194560"/>
+            <a:ext cx="18288" cy="6419088"/>
+          </a:xfrm>
+          <a:prstGeom prst="rect">
+            <a:avLst/>
+          </a:prstGeom>
+          <a:solidFill>
+            <a:srgbClr val="D9D9D9"/>
+          </a:solidFill>
+          <a:ln>
+            <a:noFill/>
+          </a:ln>
+          <a:effectLst/>
+        </p:spPr>
+        <p:style>
+          <a:lnRef idx="1">
+            <a:schemeClr val="accent1"/>
+          </a:lnRef>
+          <a:fillRef idx="3">
+            <a:schemeClr val="accent1"/>
+          </a:fillRef>
+          <a:effectRef idx="2">
+            <a:schemeClr val="accent1"/>
+          </a:effectRef>
+          <a:fontRef idx="minor">
+            <a:schemeClr val="lt1"/>
+          </a:fontRef>
+        </p:style>
+        <p:txBody>
+          <a:bodyPr rtlCol="0" anchor="ctr"/>
+          <a:lstStyle/>
+          <a:p>
+            <a:pPr algn="ctr"/>
+          </a:p>
+        </p:txBody>
+      </p:sp>
+      <p:sp>
+        <p:nvSpPr>
+          <p:cNvPr id="7" name="Oval 6"/>
+          <p:cNvSpPr/>
+          <p:nvPr/>
+        </p:nvSpPr>
+        <p:spPr>
+          <a:xfrm>
+            <a:off x="722376" y="2139696"/>
+            <a:ext cx="438912" cy="438912"/>
+          </a:xfrm>
+          <a:prstGeom prst="ellipse">
+            <a:avLst/>
+          </a:prstGeom>
+          <a:solidFill>
+            <a:srgbClr val="E8590C"/>
+          </a:solidFill>
+          <a:ln>
+            <a:noFill/>
+          </a:ln>
+          <a:effectLst/>
+        </p:spPr>
+        <p:style>
+          <a:lnRef idx="1">
+            <a:schemeClr val="accent1"/>
+          </a:lnRef>
+          <a:fillRef idx="3">
+            <a:schemeClr val="accent1"/>
+          </a:fillRef>
+          <a:effectRef idx="2">
+            <a:schemeClr val="accent1"/>
+          </a:effectRef>
+          <a:fontRef idx="minor">
+            <a:schemeClr val="lt1"/>
+          </a:fontRef>
+        </p:style>
+        <p:txBody>
+          <a:bodyPr rtlCol="0" anchor="ctr"/>
+          <a:lstStyle/>
+          <a:p>
+            <a:pPr algn="ctr"/>
+          </a:p>
+        </p:txBody>
+      </p:sp>
+      <p:sp>
+        <p:nvSpPr>
+          <p:cNvPr id="8" name="TextBox 7"/>
+          <p:cNvSpPr txBox="1"/>
+          <p:nvPr/>
+        </p:nvSpPr>
+        <p:spPr>
+          <a:xfrm>
+            <a:off x="722376" y="2139696"/>
+            <a:ext cx="438912" cy="438912"/>
+          </a:xfrm>
+          <a:prstGeom prst="rect">
+            <a:avLst/>
+          </a:prstGeom>
+          <a:noFill/>
+        </p:spPr>
+        <p:txBody>
+          <a:bodyPr wrap="square" anchor="ctr" lIns="0" rIns="0" tIns="0" bIns="0">
+            <a:spAutoFit/>
+          </a:bodyPr>
+          <a:lstStyle/>
+          <a:p>
+            <a:pPr algn="ctr">
+              <a:lnSpc>
+                <a:spcPct val="110000"/>
+              </a:lnSpc>
+            </a:pPr>
+            <a:r>
+              <a:rPr sz="2000" b="1">
+                <a:solidFill>
+                  <a:srgbClr val="FFFFFF"/>
+                </a:solidFill>
+                <a:latin typeface="Arial"/>
+                <a:ea typeface="Arial"/>
+              </a:rPr>
+              <a:t>1</a:t>
+            </a:r>
+          </a:p>
+        </p:txBody>
+      </p:sp>
+      <p:sp>
+        <p:nvSpPr>
+          <p:cNvPr id="9" name="TextBox 8"/>
+          <p:cNvSpPr txBox="1"/>
+          <p:nvPr/>
+        </p:nvSpPr>
+        <p:spPr>
+          <a:xfrm>
+            <a:off x="1307592" y="2103120"/>
+            <a:ext cx="7424927" cy="512063"/>
+          </a:xfrm>
+          <a:prstGeom prst="rect">
+            <a:avLst/>
+          </a:prstGeom>
+          <a:noFill/>
+        </p:spPr>
+        <p:txBody>
+          <a:bodyPr wrap="square" anchor="ctr" lIns="0" rIns="0" tIns="0" bIns="0">
+            <a:spAutoFit/>
+          </a:bodyPr>
+          <a:lstStyle/>
+          <a:p>
+            <a:pPr algn="l">
+              <a:lnSpc>
+                <a:spcPct val="110000"/>
+              </a:lnSpc>
+            </a:pPr>
+            <a:r>
+              <a:rPr sz="2400" b="1">
+                <a:solidFill>
+                  <a:srgbClr val="1A1A1A"/>
+                </a:solidFill>
+                <a:latin typeface="Arial"/>
+                <a:ea typeface="Arial"/>
+              </a:rPr>
+              <a:t>위기: Shrink 장벽 · 후발 추격</a:t>
+            </a:r>
+          </a:p>
+        </p:txBody>
+      </p:sp>
+      <p:sp>
+        <p:nvSpPr>
+          <p:cNvPr id="10" name="Oval 9"/>
+          <p:cNvSpPr/>
+          <p:nvPr/>
+        </p:nvSpPr>
+        <p:spPr>
+          <a:xfrm>
+            <a:off x="9372600" y="2139696"/>
+            <a:ext cx="438912" cy="438912"/>
+          </a:xfrm>
+          <a:prstGeom prst="ellipse">
+            <a:avLst/>
+          </a:prstGeom>
+          <a:solidFill>
+            <a:srgbClr val="0E9384"/>
+          </a:solidFill>
+          <a:ln>
+            <a:noFill/>
+          </a:ln>
+          <a:effectLst/>
+        </p:spPr>
+        <p:style>
+          <a:lnRef idx="1">
+            <a:schemeClr val="accent1"/>
+          </a:lnRef>
+          <a:fillRef idx="3">
+            <a:schemeClr val="accent1"/>
+          </a:fillRef>
+          <a:effectRef idx="2">
+            <a:schemeClr val="accent1"/>
+          </a:effectRef>
+          <a:fontRef idx="minor">
+            <a:schemeClr val="lt1"/>
+          </a:fontRef>
+        </p:style>
+        <p:txBody>
+          <a:bodyPr rtlCol="0" anchor="ctr"/>
+          <a:lstStyle/>
+          <a:p>
+            <a:pPr algn="ctr"/>
+          </a:p>
+        </p:txBody>
+      </p:sp>
+      <p:sp>
+        <p:nvSpPr>
+          <p:cNvPr id="11" name="TextBox 10"/>
+          <p:cNvSpPr txBox="1"/>
+          <p:nvPr/>
+        </p:nvSpPr>
+        <p:spPr>
+          <a:xfrm>
+            <a:off x="9372600" y="2139696"/>
+            <a:ext cx="438912" cy="438912"/>
+          </a:xfrm>
+          <a:prstGeom prst="rect">
+            <a:avLst/>
+          </a:prstGeom>
+          <a:noFill/>
+        </p:spPr>
+        <p:txBody>
+          <a:bodyPr wrap="square" anchor="ctr" lIns="0" rIns="0" tIns="0" bIns="0">
+            <a:spAutoFit/>
+          </a:bodyPr>
+          <a:lstStyle/>
+          <a:p>
+            <a:pPr algn="ctr">
+              <a:lnSpc>
+                <a:spcPct val="110000"/>
+              </a:lnSpc>
+            </a:pPr>
+            <a:r>
+              <a:rPr sz="2000" b="1">
+                <a:solidFill>
+                  <a:srgbClr val="FFFFFF"/>
+                </a:solidFill>
+                <a:latin typeface="Arial"/>
+                <a:ea typeface="Arial"/>
+              </a:rPr>
+              <a:t>2</a:t>
+            </a:r>
+          </a:p>
+        </p:txBody>
+      </p:sp>
+      <p:sp>
+        <p:nvSpPr>
+          <p:cNvPr id="12" name="TextBox 11"/>
+          <p:cNvSpPr txBox="1"/>
+          <p:nvPr/>
+        </p:nvSpPr>
+        <p:spPr>
+          <a:xfrm>
+            <a:off x="9957816" y="2103120"/>
+            <a:ext cx="7607808" cy="512063"/>
+          </a:xfrm>
+          <a:prstGeom prst="rect">
+            <a:avLst/>
+          </a:prstGeom>
+          <a:noFill/>
+        </p:spPr>
+        <p:txBody>
+          <a:bodyPr wrap="square" anchor="ctr" lIns="0" rIns="0" tIns="0" bIns="0">
+            <a:spAutoFit/>
+          </a:bodyPr>
+          <a:lstStyle/>
+          <a:p>
+            <a:pPr algn="l">
+              <a:lnSpc>
+                <a:spcPct val="110000"/>
+              </a:lnSpc>
+            </a:pPr>
+            <a:r>
+              <a:rPr sz="2400" b="1">
+                <a:solidFill>
+                  <a:srgbClr val="1A1A1A"/>
+                </a:solidFill>
+                <a:latin typeface="Arial"/>
+                <a:ea typeface="Arial"/>
+              </a:rPr>
+              <a:t>기회: 추론의 병목은 메모리</a:t>
+            </a:r>
+          </a:p>
+        </p:txBody>
+      </p:sp>
+      <p:sp>
+        <p:nvSpPr>
+          <p:cNvPr id="13" name="Rectangle 12"/>
+          <p:cNvSpPr/>
+          <p:nvPr/>
+        </p:nvSpPr>
+        <p:spPr>
+          <a:xfrm>
+            <a:off x="722376" y="8778240"/>
+            <a:ext cx="16843248" cy="731520"/>
+          </a:xfrm>
+          <a:prstGeom prst="rect">
+            <a:avLst/>
+          </a:prstGeom>
+          <a:solidFill>
+            <a:srgbClr val="3C4FA5"/>
+          </a:solidFill>
+          <a:ln>
+            <a:noFill/>
+          </a:ln>
+          <a:effectLst/>
+        </p:spPr>
+        <p:style>
+          <a:lnRef idx="1">
+            <a:schemeClr val="accent1"/>
+          </a:lnRef>
+          <a:fillRef idx="3">
+            <a:schemeClr val="accent1"/>
+          </a:fillRef>
+          <a:effectRef idx="2">
+            <a:schemeClr val="accent1"/>
+          </a:effectRef>
+          <a:fontRef idx="minor">
+            <a:schemeClr val="lt1"/>
+          </a:fontRef>
+        </p:style>
+        <p:txBody>
+          <a:bodyPr rtlCol="0" anchor="ctr"/>
+          <a:lstStyle/>
+          <a:p>
+            <a:pPr algn="ctr"/>
+          </a:p>
+        </p:txBody>
+      </p:sp>
+      <p:sp>
+        <p:nvSpPr>
+          <p:cNvPr id="14" name="TextBox 13"/>
+          <p:cNvSpPr txBox="1"/>
+          <p:nvPr/>
+        </p:nvSpPr>
+        <p:spPr>
+          <a:xfrm>
+            <a:off x="1088136" y="8778240"/>
+            <a:ext cx="1234440" cy="731520"/>
+          </a:xfrm>
+          <a:prstGeom prst="rect">
+            <a:avLst/>
+          </a:prstGeom>
+          <a:noFill/>
+        </p:spPr>
+        <p:txBody>
+          <a:bodyPr wrap="square" anchor="ctr" lIns="0" rIns="0" tIns="0" bIns="0">
+            <a:spAutoFit/>
+          </a:bodyPr>
+          <a:lstStyle/>
+          <a:p>
+            <a:pPr algn="l">
+              <a:lnSpc>
+                <a:spcPct val="110000"/>
+              </a:lnSpc>
+            </a:pPr>
+            <a:r>
+              <a:rPr sz="2000" b="0">
+                <a:solidFill>
+                  <a:srgbClr val="C0CAEC"/>
+                </a:solidFill>
+                <a:latin typeface="Arial"/>
+                <a:ea typeface="Arial"/>
+              </a:rPr>
+              <a:t>현실</a:t>
+            </a:r>
+          </a:p>
+        </p:txBody>
+      </p:sp>
+      <p:sp>
+        <p:nvSpPr>
+          <p:cNvPr id="15" name="TextBox 14"/>
+          <p:cNvSpPr txBox="1"/>
+          <p:nvPr/>
+        </p:nvSpPr>
+        <p:spPr>
+          <a:xfrm>
+            <a:off x="2322576" y="8778240"/>
+            <a:ext cx="15060168" cy="731520"/>
+          </a:xfrm>
+          <a:prstGeom prst="rect">
+            <a:avLst/>
+          </a:prstGeom>
+          <a:noFill/>
+        </p:spPr>
+        <p:txBody>
+          <a:bodyPr wrap="square" anchor="ctr" lIns="0" rIns="0" tIns="0" bIns="0">
+            <a:spAutoFit/>
+          </a:bodyPr>
+          <a:lstStyle/>
+          <a:p>
+            <a:pPr algn="l">
+              <a:lnSpc>
+                <a:spcPct val="110000"/>
+              </a:lnSpc>
+            </a:pPr>
+            <a:r>
+              <a:rPr sz="2400" b="1">
+                <a:solidFill>
+                  <a:srgbClr val="FFFFFF"/>
+                </a:solidFill>
+                <a:latin typeface="Arial"/>
+                <a:ea typeface="Arial"/>
+              </a:rPr>
+              <a:t>Shrink만으로는 격차를 지킬 수 없다. 차별화는 AI 추론의 메모리 병목에서 찾는다</a:t>
+            </a:r>
+          </a:p>
+        </p:txBody>
+      </p:sp>
+      <p:pic>
+        <p:nvPicPr>
+          <p:cNvPr id="16" name="Picture 15" descr="node_simple_linear.png"/>
+          <p:cNvPicPr>
+            <a:picLocks noChangeAspect="1"/>
+          </p:cNvPicPr>
+          <p:nvPr/>
+        </p:nvPicPr>
+        <p:blipFill>
+          <a:blip r:embed="rId2"/>
+          <a:stretch>
+            <a:fillRect/>
+          </a:stretch>
+        </p:blipFill>
+        <p:spPr>
+          <a:xfrm>
+            <a:off x="722376" y="2724912"/>
+            <a:ext cx="8010144" cy="5852160"/>
+          </a:xfrm>
+          <a:prstGeom prst="rect">
+            <a:avLst/>
+          </a:prstGeom>
+        </p:spPr>
+      </p:pic>
+      <p:sp>
+        <p:nvSpPr>
+          <p:cNvPr id="17" name="TextBox 16"/>
+          <p:cNvSpPr txBox="1"/>
+          <p:nvPr/>
+        </p:nvSpPr>
+        <p:spPr>
+          <a:xfrm>
+            <a:off x="9372600" y="2724912"/>
+            <a:ext cx="3474720" cy="365760"/>
+          </a:xfrm>
+          <a:prstGeom prst="rect">
+            <a:avLst/>
+          </a:prstGeom>
+          <a:noFill/>
+        </p:spPr>
+        <p:txBody>
+          <a:bodyPr wrap="square" anchor="ctr" lIns="0" rIns="0" tIns="0" bIns="0">
+            <a:spAutoFit/>
+          </a:bodyPr>
+          <a:lstStyle/>
+          <a:p>
+            <a:pPr algn="ctr">
+              <a:lnSpc>
+                <a:spcPct val="110000"/>
+              </a:lnSpc>
+            </a:pPr>
+            <a:r>
+              <a:rPr sz="2200" b="1">
+                <a:solidFill>
+                  <a:srgbClr val="6941C6"/>
+                </a:solidFill>
+                <a:latin typeface="Arial"/>
+                <a:ea typeface="Arial"/>
+              </a:rPr>
+              <a:t>알고리즘</a:t>
+            </a:r>
+          </a:p>
+        </p:txBody>
+      </p:sp>
+      <p:pic>
+        <p:nvPicPr>
+          <p:cNvPr id="18" name="Picture 17" descr="flywheel.png"/>
+          <p:cNvPicPr>
+            <a:picLocks noChangeAspect="1"/>
+          </p:cNvPicPr>
+          <p:nvPr/>
+        </p:nvPicPr>
+        <p:blipFill>
+          <a:blip r:embed="rId3"/>
+          <a:stretch>
+            <a:fillRect/>
+          </a:stretch>
+        </p:blipFill>
+        <p:spPr>
+          <a:xfrm>
+            <a:off x="9601200" y="3108960"/>
+            <a:ext cx="3017520" cy="3017520"/>
+          </a:xfrm>
+          <a:prstGeom prst="rect">
+            <a:avLst/>
+          </a:prstGeom>
+        </p:spPr>
+      </p:pic>
+      <p:pic>
+        <p:nvPicPr>
+          <p:cNvPr id="19" name="Picture 18" descr="render_hbm.png"/>
+          <p:cNvPicPr>
+            <a:picLocks noChangeAspect="1"/>
+          </p:cNvPicPr>
+          <p:nvPr/>
+        </p:nvPicPr>
+        <p:blipFill>
+          <a:blip r:embed="rId4"/>
+          <a:stretch>
+            <a:fillRect/>
+          </a:stretch>
+        </p:blipFill>
+        <p:spPr>
+          <a:xfrm>
+            <a:off x="10241280" y="3982519"/>
+            <a:ext cx="1737360" cy="1270401"/>
+          </a:xfrm>
+          <a:prstGeom prst="rect">
+            <a:avLst/>
+          </a:prstGeom>
+        </p:spPr>
+      </p:pic>
+      <p:sp>
+        <p:nvSpPr>
+          <p:cNvPr id="20" name="TextBox 19"/>
+          <p:cNvSpPr txBox="1"/>
+          <p:nvPr/>
+        </p:nvSpPr>
+        <p:spPr>
+          <a:xfrm>
+            <a:off x="9372600" y="6144767"/>
+            <a:ext cx="3474720" cy="365760"/>
+          </a:xfrm>
+          <a:prstGeom prst="rect">
+            <a:avLst/>
+          </a:prstGeom>
+          <a:noFill/>
+        </p:spPr>
+        <p:txBody>
+          <a:bodyPr wrap="square" anchor="ctr" lIns="0" rIns="0" tIns="0" bIns="0">
+            <a:spAutoFit/>
+          </a:bodyPr>
+          <a:lstStyle/>
+          <a:p>
+            <a:pPr algn="ctr">
+              <a:lnSpc>
+                <a:spcPct val="110000"/>
+              </a:lnSpc>
+            </a:pPr>
+            <a:r>
+              <a:rPr sz="2200" b="1">
+                <a:solidFill>
+                  <a:srgbClr val="0E9384"/>
+                </a:solidFill>
+                <a:latin typeface="Arial"/>
+                <a:ea typeface="Arial"/>
+              </a:rPr>
+              <a:t>메모리</a:t>
+            </a:r>
+          </a:p>
+        </p:txBody>
+      </p:sp>
+      <p:sp>
+        <p:nvSpPr>
+          <p:cNvPr id="21" name="TextBox 20"/>
+          <p:cNvSpPr txBox="1"/>
+          <p:nvPr/>
+        </p:nvSpPr>
+        <p:spPr>
+          <a:xfrm>
+            <a:off x="13075920" y="3017520"/>
+            <a:ext cx="4489704" cy="365760"/>
+          </a:xfrm>
+          <a:prstGeom prst="rect">
+            <a:avLst/>
+          </a:prstGeom>
+          <a:noFill/>
+        </p:spPr>
+        <p:txBody>
+          <a:bodyPr wrap="square" anchor="ctr" lIns="0" rIns="0" tIns="0" bIns="0">
+            <a:spAutoFit/>
+          </a:bodyPr>
+          <a:lstStyle/>
+          <a:p>
+            <a:pPr algn="l">
+              <a:lnSpc>
+                <a:spcPct val="110000"/>
+              </a:lnSpc>
+            </a:pPr>
+            <a:r>
+              <a:rPr sz="2000" b="1">
+                <a:solidFill>
+                  <a:srgbClr val="1A1A1A"/>
+                </a:solidFill>
+                <a:latin typeface="Arial"/>
+                <a:ea typeface="Arial"/>
+              </a:rPr>
+              <a:t>KV를 담을 HBM 가속기</a:t>
+            </a:r>
+          </a:p>
+        </p:txBody>
+      </p:sp>
+      <p:sp>
+        <p:nvSpPr>
+          <p:cNvPr id="22" name="TextBox 21"/>
+          <p:cNvSpPr txBox="1"/>
+          <p:nvPr/>
+        </p:nvSpPr>
+        <p:spPr>
+          <a:xfrm>
+            <a:off x="13075920" y="3419856"/>
+            <a:ext cx="4489704" cy="868680"/>
+          </a:xfrm>
+          <a:prstGeom prst="rect">
+            <a:avLst/>
+          </a:prstGeom>
+          <a:noFill/>
+        </p:spPr>
+        <p:txBody>
+          <a:bodyPr wrap="square" anchor="ctr" lIns="0" rIns="0" tIns="0" bIns="0">
+            <a:spAutoFit/>
+          </a:bodyPr>
+          <a:lstStyle/>
+          <a:p>
+            <a:pPr algn="l">
+              <a:lnSpc>
+                <a:spcPct val="110000"/>
+              </a:lnSpc>
+            </a:pPr>
+            <a:r>
+              <a:rPr sz="4800" b="1">
+                <a:solidFill>
+                  <a:srgbClr val="D93025"/>
+                </a:solidFill>
+                <a:latin typeface="Arial"/>
+                <a:ea typeface="Arial"/>
+              </a:rPr>
+              <a:t>8만~42만 개</a:t>
+            </a:r>
+          </a:p>
+        </p:txBody>
+      </p:sp>
+      <p:sp>
+        <p:nvSpPr>
+          <p:cNvPr id="23" name="TextBox 22"/>
+          <p:cNvSpPr txBox="1"/>
+          <p:nvPr/>
+        </p:nvSpPr>
+        <p:spPr>
+          <a:xfrm>
+            <a:off x="13075920" y="4315968"/>
+            <a:ext cx="4489704" cy="603504"/>
+          </a:xfrm>
+          <a:prstGeom prst="rect">
+            <a:avLst/>
+          </a:prstGeom>
+          <a:noFill/>
+        </p:spPr>
+        <p:txBody>
+          <a:bodyPr wrap="square" anchor="t" lIns="0" rIns="0" tIns="0" bIns="0">
+            <a:spAutoFit/>
+          </a:bodyPr>
+          <a:lstStyle/>
+          <a:p>
+            <a:pPr algn="l">
+              <a:lnSpc>
+                <a:spcPct val="105000"/>
+              </a:lnSpc>
+            </a:pPr>
+            <a:r>
+              <a:rPr sz="1700" b="0">
+                <a:solidFill>
+                  <a:srgbClr val="555555"/>
+                </a:solidFill>
+                <a:latin typeface="Arial"/>
+                <a:ea typeface="Arial"/>
+              </a:rPr>
+              <a:t>320 KiB × 월 3,200조 토큰</a:t>
+            </a:r>
+          </a:p>
+          <a:p>
+            <a:pPr algn="l">
+              <a:lnSpc>
+                <a:spcPct val="105000"/>
+              </a:lnSpc>
+            </a:pPr>
+            <a:r>
+              <a:rPr sz="1700" b="0">
+                <a:solidFill>
+                  <a:srgbClr val="555555"/>
+                </a:solidFill>
+                <a:latin typeface="Arial"/>
+                <a:ea typeface="Arial"/>
+              </a:rPr>
+              <a:t>288GB · 체류 60초~5분 가정</a:t>
+            </a:r>
+          </a:p>
+        </p:txBody>
+      </p:sp>
+      <p:sp>
+        <p:nvSpPr>
+          <p:cNvPr id="24" name="Rectangle 23"/>
+          <p:cNvSpPr/>
+          <p:nvPr/>
+        </p:nvSpPr>
+        <p:spPr>
+          <a:xfrm>
+            <a:off x="13075920" y="5138928"/>
+            <a:ext cx="4489704" cy="18288"/>
+          </a:xfrm>
+          <a:prstGeom prst="rect">
+            <a:avLst/>
+          </a:prstGeom>
+          <a:solidFill>
+            <a:srgbClr val="D9D9D9"/>
+          </a:solidFill>
+          <a:ln>
+            <a:noFill/>
+          </a:ln>
+          <a:effectLst/>
+        </p:spPr>
+        <p:style>
+          <a:lnRef idx="1">
+            <a:schemeClr val="accent1"/>
+          </a:lnRef>
+          <a:fillRef idx="3">
+            <a:schemeClr val="accent1"/>
+          </a:fillRef>
+          <a:effectRef idx="2">
+            <a:schemeClr val="accent1"/>
+          </a:effectRef>
+          <a:fontRef idx="minor">
+            <a:schemeClr val="lt1"/>
+          </a:fontRef>
+        </p:style>
+        <p:txBody>
+          <a:bodyPr rtlCol="0" anchor="ctr"/>
+          <a:lstStyle/>
+          <a:p>
+            <a:pPr algn="ctr"/>
+          </a:p>
+        </p:txBody>
+      </p:sp>
+      <p:sp>
+        <p:nvSpPr>
+          <p:cNvPr id="25" name="TextBox 24"/>
+          <p:cNvSpPr txBox="1"/>
+          <p:nvPr/>
+        </p:nvSpPr>
+        <p:spPr>
+          <a:xfrm>
+            <a:off x="13075920" y="5303520"/>
+            <a:ext cx="4489704" cy="365760"/>
+          </a:xfrm>
+          <a:prstGeom prst="rect">
+            <a:avLst/>
+          </a:prstGeom>
+          <a:noFill/>
+        </p:spPr>
+        <p:txBody>
+          <a:bodyPr wrap="square" anchor="ctr" lIns="0" rIns="0" tIns="0" bIns="0">
+            <a:spAutoFit/>
+          </a:bodyPr>
+          <a:lstStyle/>
+          <a:p>
+            <a:pPr algn="l">
+              <a:lnSpc>
+                <a:spcPct val="110000"/>
+              </a:lnSpc>
+            </a:pPr>
+            <a:r>
+              <a:rPr sz="2000" b="1">
+                <a:solidFill>
+                  <a:srgbClr val="1A1A1A"/>
+                </a:solidFill>
+                <a:latin typeface="Arial"/>
+                <a:ea typeface="Arial"/>
+              </a:rPr>
+              <a:t>메모리 공급 확대</a:t>
+            </a:r>
+          </a:p>
+        </p:txBody>
+      </p:sp>
+      <p:sp>
+        <p:nvSpPr>
+          <p:cNvPr id="26" name="TextBox 25"/>
+          <p:cNvSpPr txBox="1"/>
+          <p:nvPr/>
+        </p:nvSpPr>
+        <p:spPr>
+          <a:xfrm>
+            <a:off x="13075920" y="5669280"/>
+            <a:ext cx="4489704" cy="731520"/>
+          </a:xfrm>
+          <a:prstGeom prst="rect">
+            <a:avLst/>
+          </a:prstGeom>
+          <a:noFill/>
+        </p:spPr>
+        <p:txBody>
+          <a:bodyPr wrap="square" anchor="ctr" lIns="0" rIns="0" tIns="0" bIns="0">
+            <a:spAutoFit/>
+          </a:bodyPr>
+          <a:lstStyle/>
+          <a:p>
+            <a:pPr algn="l">
+              <a:lnSpc>
+                <a:spcPct val="110000"/>
+              </a:lnSpc>
+            </a:pPr>
+            <a:r>
+              <a:rPr sz="4400" b="1">
+                <a:solidFill>
+                  <a:srgbClr val="D93025"/>
+                </a:solidFill>
+                <a:latin typeface="Arial"/>
+                <a:ea typeface="Arial"/>
+              </a:rPr>
+              <a:t>2028</a:t>
+            </a:r>
+            <a:r>
+              <a:rPr sz="2000" b="1">
+                <a:solidFill>
+                  <a:srgbClr val="1A1A1A"/>
+                </a:solidFill>
+                <a:latin typeface="Arial"/>
+                <a:ea typeface="Arial"/>
+              </a:rPr>
+              <a:t>  년부터</a:t>
+            </a:r>
+          </a:p>
+        </p:txBody>
+      </p:sp>
+      <p:sp>
+        <p:nvSpPr>
+          <p:cNvPr id="27" name="TextBox 26"/>
+          <p:cNvSpPr txBox="1"/>
+          <p:nvPr/>
+        </p:nvSpPr>
+        <p:spPr>
+          <a:xfrm>
+            <a:off x="9372600" y="6547104"/>
+            <a:ext cx="8193024" cy="256032"/>
+          </a:xfrm>
+          <a:prstGeom prst="rect">
+            <a:avLst/>
+          </a:prstGeom>
+          <a:noFill/>
+        </p:spPr>
+        <p:txBody>
+          <a:bodyPr wrap="square" anchor="ctr" lIns="0" rIns="0" tIns="0" bIns="0">
+            <a:spAutoFit/>
+          </a:bodyPr>
+          <a:lstStyle/>
+          <a:p>
+            <a:pPr algn="l">
+              <a:lnSpc>
+                <a:spcPct val="110000"/>
+              </a:lnSpc>
+            </a:pPr>
+            <a:r>
+              <a:rPr sz="1500" b="0">
+                <a:solidFill>
+                  <a:srgbClr val="555555"/>
+                </a:solidFill>
+                <a:latin typeface="Arial"/>
+                <a:ea typeface="Arial"/>
+              </a:rPr>
+              <a:t>토큰당 KV 절감(70B, MHA → GQA · FP4) vs 토큰 증가(Google, 2년)</a:t>
+            </a:r>
+          </a:p>
+        </p:txBody>
+      </p:sp>
+      <p:pic>
+        <p:nvPicPr>
+          <p:cNvPr id="28" name="Picture 27" descr="tug2.png"/>
+          <p:cNvPicPr>
+            <a:picLocks noChangeAspect="1"/>
+          </p:cNvPicPr>
+          <p:nvPr/>
+        </p:nvPicPr>
+        <p:blipFill>
+          <a:blip r:embed="rId5"/>
+          <a:stretch>
+            <a:fillRect/>
+          </a:stretch>
+        </p:blipFill>
+        <p:spPr>
+          <a:xfrm>
+            <a:off x="9567672" y="6784848"/>
+            <a:ext cx="7802880" cy="1828800"/>
+          </a:xfrm>
+          <a:prstGeom prst="rect">
+            <a:avLst/>
+          </a:prstGeom>
+        </p:spPr>
+      </p:pic>
+      <p:sp>
+        <p:nvSpPr>
+          <p:cNvPr id="29" name="TextBox 28"/>
+          <p:cNvSpPr txBox="1"/>
+          <p:nvPr/>
+        </p:nvSpPr>
+        <p:spPr>
+          <a:xfrm>
+            <a:off x="722376" y="9601200"/>
+            <a:ext cx="15453359" cy="310896"/>
+          </a:xfrm>
+          <a:prstGeom prst="rect">
+            <a:avLst/>
+          </a:prstGeom>
+          <a:noFill/>
+        </p:spPr>
+        <p:txBody>
+          <a:bodyPr wrap="square" anchor="t" lIns="0" rIns="0" tIns="0" bIns="0">
+            <a:spAutoFit/>
+          </a:bodyPr>
+          <a:lstStyle/>
+          <a:p>
+            <a:pPr algn="l">
+              <a:lnSpc>
+                <a:spcPct val="110000"/>
+              </a:lnSpc>
+            </a:pPr>
+            <a:r>
+              <a:rPr sz="1500" b="0">
+                <a:solidFill>
+                  <a:srgbClr val="555555"/>
+                </a:solidFill>
+                <a:latin typeface="Arial"/>
+                <a:ea typeface="Arial"/>
+              </a:rPr>
+              <a:t>출처: ITRS · TechInsights · Fab Tracker Q2'26 · Digitimes / Llama 3.1 설정 산식 · Google I/O · TrendForce 2026-07 · 산술은 가정 의존 · 부품은 3D 렌더 · 상세 근거는 시안 A~C</a:t>
+            </a:r>
+          </a:p>
+        </p:txBody>
+      </p:sp>
+      <p:sp>
+        <p:nvSpPr>
+          <p:cNvPr id="30" name="TextBox 29"/>
+          <p:cNvSpPr txBox="1"/>
+          <p:nvPr/>
+        </p:nvSpPr>
+        <p:spPr>
+          <a:xfrm>
+            <a:off x="16102584" y="9601200"/>
+            <a:ext cx="1463040" cy="310896"/>
+          </a:xfrm>
+          <a:prstGeom prst="rect">
+            <a:avLst/>
+          </a:prstGeom>
+          <a:noFill/>
+        </p:spPr>
+        <p:txBody>
+          <a:bodyPr wrap="square" anchor="t" lIns="0" rIns="0" tIns="0" bIns="0">
+            <a:spAutoFit/>
+          </a:bodyPr>
+          <a:lstStyle/>
+          <a:p>
+            <a:pPr algn="r">
+              <a:lnSpc>
+                <a:spcPct val="110000"/>
+              </a:lnSpc>
+            </a:pPr>
+            <a:r>
+              <a:rPr sz="1600" b="1">
+                <a:solidFill>
+                  <a:srgbClr val="555555"/>
+                </a:solidFill>
+                <a:latin typeface="Arial"/>
+                <a:ea typeface="Arial"/>
+              </a:rPr>
+              <a:t>시안 B2</a:t>
+            </a:r>
+          </a:p>
+        </p:txBody>
+      </p:sp>
+    </p:spTree>
+  </p:cSld>
+  <p:clrMapOvr>
+    <a:masterClrMapping/>
+  </p:clrMapOvr>
+</p:sld>
+</file>
+
+<file path=ppt/slides/slide6.xml><?xml version="1.0" encoding="utf-8"?>
+<p:sld xmlns:a="http://schemas.openxmlformats.org/drawingml/2006/main" xmlns:p="http://schemas.openxmlformats.org/presentationml/2006/main" xmlns:r="http://schemas.openxmlformats.org/officeDocument/2006/relationships">
+  <p:cSld>
+    <p:spTree>
+      <p:nvGrpSpPr>
+        <p:cNvPr id="1" name=""/>
+        <p:cNvGrpSpPr/>
+        <p:nvPr/>
+      </p:nvGrpSpPr>
+      <p:grpSpPr/>
+      <p:sp>
+        <p:nvSpPr>
+          <p:cNvPr id="2" name="TextBox 1"/>
+          <p:cNvSpPr txBox="1"/>
+          <p:nvPr/>
+        </p:nvSpPr>
+        <p:spPr>
+          <a:xfrm>
+            <a:off x="722376" y="365760"/>
+            <a:ext cx="10972800" cy="329184"/>
+          </a:xfrm>
+          <a:prstGeom prst="rect">
+            <a:avLst/>
+          </a:prstGeom>
+          <a:noFill/>
+        </p:spPr>
+        <p:txBody>
+          <a:bodyPr wrap="square" anchor="t" lIns="0" rIns="0" tIns="0" bIns="0">
+            <a:spAutoFit/>
+          </a:bodyPr>
+          <a:lstStyle/>
+          <a:p>
+            <a:pPr algn="l">
+              <a:lnSpc>
+                <a:spcPct val="110000"/>
+              </a:lnSpc>
+            </a:pPr>
+            <a:r>
+              <a:rPr sz="1800" b="1">
+                <a:solidFill>
+                  <a:srgbClr val="3C4FA5"/>
+                </a:solidFill>
+                <a:latin typeface="Arial"/>
+                <a:ea typeface="Arial"/>
+              </a:rPr>
+              <a:t>DRAM 기술 경쟁력 제고 · 차별화 준비</a:t>
+            </a:r>
+            <a:r>
+              <a:rPr sz="1800" b="0">
+                <a:solidFill>
+                  <a:srgbClr val="555555"/>
+                </a:solidFill>
+                <a:latin typeface="Arial"/>
+                <a:ea typeface="Arial"/>
+              </a:rPr>
+              <a:t>   6 / 6  현실 파악 · 시안 C2 실물형 간결</a:t>
+            </a:r>
+          </a:p>
+        </p:txBody>
+      </p:sp>
+      <p:sp>
+        <p:nvSpPr>
+          <p:cNvPr id="3" name="TextBox 2"/>
+          <p:cNvSpPr txBox="1"/>
+          <p:nvPr/>
+        </p:nvSpPr>
+        <p:spPr>
+          <a:xfrm>
+            <a:off x="12079224" y="365760"/>
+            <a:ext cx="5486400" cy="329184"/>
+          </a:xfrm>
+          <a:prstGeom prst="rect">
+            <a:avLst/>
+          </a:prstGeom>
+          <a:noFill/>
+        </p:spPr>
+        <p:txBody>
+          <a:bodyPr wrap="square" anchor="t" lIns="0" rIns="0" tIns="0" bIns="0">
+            <a:spAutoFit/>
+          </a:bodyPr>
+          <a:lstStyle/>
+          <a:p>
+            <a:pPr algn="r">
+              <a:lnSpc>
+                <a:spcPct val="110000"/>
+              </a:lnSpc>
+            </a:pPr>
+            <a:r>
+              <a:rPr sz="1800" b="0">
+                <a:solidFill>
+                  <a:srgbClr val="555555"/>
+                </a:solidFill>
+                <a:latin typeface="Arial"/>
+                <a:ea typeface="Arial"/>
+              </a:rPr>
+              <a:t>[문서등급 표기]</a:t>
+            </a:r>
+          </a:p>
+        </p:txBody>
+      </p:sp>
+      <p:sp>
+        <p:nvSpPr>
+          <p:cNvPr id="4" name="TextBox 3"/>
+          <p:cNvSpPr txBox="1"/>
+          <p:nvPr/>
+        </p:nvSpPr>
+        <p:spPr>
+          <a:xfrm>
+            <a:off x="722376" y="786384"/>
+            <a:ext cx="16843248" cy="1024128"/>
+          </a:xfrm>
+          <a:prstGeom prst="rect">
+            <a:avLst/>
+          </a:prstGeom>
+          <a:noFill/>
+        </p:spPr>
+        <p:txBody>
+          <a:bodyPr wrap="square" anchor="ctr" lIns="0" rIns="0" tIns="0" bIns="0">
+            <a:spAutoFit/>
+          </a:bodyPr>
+          <a:lstStyle/>
+          <a:p>
+            <a:pPr algn="l">
+              <a:lnSpc>
+                <a:spcPct val="105000"/>
+              </a:lnSpc>
+            </a:pPr>
+            <a:r>
+              <a:rPr sz="3200" b="1">
+                <a:solidFill>
+                  <a:srgbClr val="1A1A1A"/>
+                </a:solidFill>
+                <a:latin typeface="Arial"/>
+                <a:ea typeface="Arial"/>
+              </a:rPr>
+              <a:t>DRAM은 Shrink 장벽에 막혀 후발 주자의 추격을 받고 있지만,</a:t>
+            </a:r>
+          </a:p>
+          <a:p>
+            <a:pPr algn="l">
+              <a:lnSpc>
+                <a:spcPct val="105000"/>
+              </a:lnSpc>
+            </a:pPr>
+            <a:r>
+              <a:rPr sz="3200" b="1">
+                <a:solidFill>
+                  <a:srgbClr val="1A1A1A"/>
+                </a:solidFill>
+                <a:latin typeface="Arial"/>
+                <a:ea typeface="Arial"/>
+              </a:rPr>
+              <a:t>AI 추론의 병목이 연산에서 메모리로 옮겨 오며 차별화의 기회가 열리고 있다</a:t>
+            </a:r>
+          </a:p>
+        </p:txBody>
+      </p:sp>
+      <p:sp>
+        <p:nvSpPr>
+          <p:cNvPr id="5" name="Rectangle 4"/>
+          <p:cNvSpPr/>
+          <p:nvPr/>
+        </p:nvSpPr>
+        <p:spPr>
+          <a:xfrm>
+            <a:off x="722376" y="1938528"/>
+            <a:ext cx="16843248" cy="18288"/>
+          </a:xfrm>
+          <a:prstGeom prst="rect">
+            <a:avLst/>
+          </a:prstGeom>
+          <a:solidFill>
+            <a:srgbClr val="D9D9D9"/>
+          </a:solidFill>
+          <a:ln>
+            <a:noFill/>
+          </a:ln>
+          <a:effectLst/>
+        </p:spPr>
+        <p:style>
+          <a:lnRef idx="1">
+            <a:schemeClr val="accent1"/>
+          </a:lnRef>
+          <a:fillRef idx="3">
+            <a:schemeClr val="accent1"/>
+          </a:fillRef>
+          <a:effectRef idx="2">
+            <a:schemeClr val="accent1"/>
+          </a:effectRef>
+          <a:fontRef idx="minor">
+            <a:schemeClr val="lt1"/>
+          </a:fontRef>
+        </p:style>
+        <p:txBody>
+          <a:bodyPr rtlCol="0" anchor="ctr"/>
+          <a:lstStyle/>
+          <a:p>
+            <a:pPr algn="ctr"/>
+          </a:p>
+        </p:txBody>
+      </p:sp>
+      <p:sp>
+        <p:nvSpPr>
+          <p:cNvPr id="6" name="Rectangle 5"/>
+          <p:cNvSpPr/>
+          <p:nvPr/>
+        </p:nvSpPr>
+        <p:spPr>
+          <a:xfrm>
+            <a:off x="9015984" y="2194560"/>
+            <a:ext cx="18288" cy="6419088"/>
+          </a:xfrm>
+          <a:prstGeom prst="rect">
+            <a:avLst/>
+          </a:prstGeom>
+          <a:solidFill>
+            <a:srgbClr val="D9D9D9"/>
+          </a:solidFill>
+          <a:ln>
+            <a:noFill/>
+          </a:ln>
+          <a:effectLst/>
+        </p:spPr>
+        <p:style>
+          <a:lnRef idx="1">
+            <a:schemeClr val="accent1"/>
+          </a:lnRef>
+          <a:fillRef idx="3">
+            <a:schemeClr val="accent1"/>
+          </a:fillRef>
+          <a:effectRef idx="2">
+            <a:schemeClr val="accent1"/>
+          </a:effectRef>
+          <a:fontRef idx="minor">
+            <a:schemeClr val="lt1"/>
+          </a:fontRef>
+        </p:style>
+        <p:txBody>
+          <a:bodyPr rtlCol="0" anchor="ctr"/>
+          <a:lstStyle/>
+          <a:p>
+            <a:pPr algn="ctr"/>
+          </a:p>
+        </p:txBody>
+      </p:sp>
+      <p:sp>
+        <p:nvSpPr>
+          <p:cNvPr id="7" name="Oval 6"/>
+          <p:cNvSpPr/>
+          <p:nvPr/>
+        </p:nvSpPr>
+        <p:spPr>
+          <a:xfrm>
+            <a:off x="722376" y="2139696"/>
+            <a:ext cx="438912" cy="438912"/>
+          </a:xfrm>
+          <a:prstGeom prst="ellipse">
+            <a:avLst/>
+          </a:prstGeom>
+          <a:solidFill>
+            <a:srgbClr val="E8590C"/>
+          </a:solidFill>
+          <a:ln>
+            <a:noFill/>
+          </a:ln>
+          <a:effectLst/>
+        </p:spPr>
+        <p:style>
+          <a:lnRef idx="1">
+            <a:schemeClr val="accent1"/>
+          </a:lnRef>
+          <a:fillRef idx="3">
+            <a:schemeClr val="accent1"/>
+          </a:fillRef>
+          <a:effectRef idx="2">
+            <a:schemeClr val="accent1"/>
+          </a:effectRef>
+          <a:fontRef idx="minor">
+            <a:schemeClr val="lt1"/>
+          </a:fontRef>
+        </p:style>
+        <p:txBody>
+          <a:bodyPr rtlCol="0" anchor="ctr"/>
+          <a:lstStyle/>
+          <a:p>
+            <a:pPr algn="ctr"/>
+          </a:p>
+        </p:txBody>
+      </p:sp>
+      <p:sp>
+        <p:nvSpPr>
+          <p:cNvPr id="8" name="TextBox 7"/>
+          <p:cNvSpPr txBox="1"/>
+          <p:nvPr/>
+        </p:nvSpPr>
+        <p:spPr>
+          <a:xfrm>
+            <a:off x="722376" y="2139696"/>
+            <a:ext cx="438912" cy="438912"/>
+          </a:xfrm>
+          <a:prstGeom prst="rect">
+            <a:avLst/>
+          </a:prstGeom>
+          <a:noFill/>
+        </p:spPr>
+        <p:txBody>
+          <a:bodyPr wrap="square" anchor="ctr" lIns="0" rIns="0" tIns="0" bIns="0">
+            <a:spAutoFit/>
+          </a:bodyPr>
+          <a:lstStyle/>
+          <a:p>
+            <a:pPr algn="ctr">
+              <a:lnSpc>
+                <a:spcPct val="110000"/>
+              </a:lnSpc>
+            </a:pPr>
+            <a:r>
+              <a:rPr sz="2000" b="1">
+                <a:solidFill>
+                  <a:srgbClr val="FFFFFF"/>
+                </a:solidFill>
+                <a:latin typeface="Arial"/>
+                <a:ea typeface="Arial"/>
+              </a:rPr>
+              <a:t>1</a:t>
+            </a:r>
+          </a:p>
+        </p:txBody>
+      </p:sp>
+      <p:sp>
+        <p:nvSpPr>
+          <p:cNvPr id="9" name="TextBox 8"/>
+          <p:cNvSpPr txBox="1"/>
+          <p:nvPr/>
+        </p:nvSpPr>
+        <p:spPr>
+          <a:xfrm>
+            <a:off x="1307592" y="2103120"/>
+            <a:ext cx="7424927" cy="512063"/>
+          </a:xfrm>
+          <a:prstGeom prst="rect">
+            <a:avLst/>
+          </a:prstGeom>
+          <a:noFill/>
+        </p:spPr>
+        <p:txBody>
+          <a:bodyPr wrap="square" anchor="ctr" lIns="0" rIns="0" tIns="0" bIns="0">
+            <a:spAutoFit/>
+          </a:bodyPr>
+          <a:lstStyle/>
+          <a:p>
+            <a:pPr algn="l">
+              <a:lnSpc>
+                <a:spcPct val="110000"/>
+              </a:lnSpc>
+            </a:pPr>
+            <a:r>
+              <a:rPr sz="2400" b="1">
+                <a:solidFill>
+                  <a:srgbClr val="1A1A1A"/>
+                </a:solidFill>
+                <a:latin typeface="Arial"/>
+                <a:ea typeface="Arial"/>
+              </a:rPr>
+              <a:t>위기: Shrink 장벽 · 후발 추격</a:t>
+            </a:r>
+          </a:p>
+        </p:txBody>
+      </p:sp>
+      <p:sp>
+        <p:nvSpPr>
+          <p:cNvPr id="10" name="Oval 9"/>
+          <p:cNvSpPr/>
+          <p:nvPr/>
+        </p:nvSpPr>
+        <p:spPr>
+          <a:xfrm>
+            <a:off x="9372600" y="2139696"/>
+            <a:ext cx="438912" cy="438912"/>
+          </a:xfrm>
+          <a:prstGeom prst="ellipse">
+            <a:avLst/>
+          </a:prstGeom>
+          <a:solidFill>
+            <a:srgbClr val="0E9384"/>
+          </a:solidFill>
+          <a:ln>
+            <a:noFill/>
+          </a:ln>
+          <a:effectLst/>
+        </p:spPr>
+        <p:style>
+          <a:lnRef idx="1">
+            <a:schemeClr val="accent1"/>
+          </a:lnRef>
+          <a:fillRef idx="3">
+            <a:schemeClr val="accent1"/>
+          </a:fillRef>
+          <a:effectRef idx="2">
+            <a:schemeClr val="accent1"/>
+          </a:effectRef>
+          <a:fontRef idx="minor">
+            <a:schemeClr val="lt1"/>
+          </a:fontRef>
+        </p:style>
+        <p:txBody>
+          <a:bodyPr rtlCol="0" anchor="ctr"/>
+          <a:lstStyle/>
+          <a:p>
+            <a:pPr algn="ctr"/>
+          </a:p>
+        </p:txBody>
+      </p:sp>
+      <p:sp>
+        <p:nvSpPr>
+          <p:cNvPr id="11" name="TextBox 10"/>
+          <p:cNvSpPr txBox="1"/>
+          <p:nvPr/>
+        </p:nvSpPr>
+        <p:spPr>
+          <a:xfrm>
+            <a:off x="9372600" y="2139696"/>
+            <a:ext cx="438912" cy="438912"/>
+          </a:xfrm>
+          <a:prstGeom prst="rect">
+            <a:avLst/>
+          </a:prstGeom>
+          <a:noFill/>
+        </p:spPr>
+        <p:txBody>
+          <a:bodyPr wrap="square" anchor="ctr" lIns="0" rIns="0" tIns="0" bIns="0">
+            <a:spAutoFit/>
+          </a:bodyPr>
+          <a:lstStyle/>
+          <a:p>
+            <a:pPr algn="ctr">
+              <a:lnSpc>
+                <a:spcPct val="110000"/>
+              </a:lnSpc>
+            </a:pPr>
+            <a:r>
+              <a:rPr sz="2000" b="1">
+                <a:solidFill>
+                  <a:srgbClr val="FFFFFF"/>
+                </a:solidFill>
+                <a:latin typeface="Arial"/>
+                <a:ea typeface="Arial"/>
+              </a:rPr>
+              <a:t>2</a:t>
+            </a:r>
+          </a:p>
+        </p:txBody>
+      </p:sp>
+      <p:sp>
+        <p:nvSpPr>
+          <p:cNvPr id="12" name="TextBox 11"/>
+          <p:cNvSpPr txBox="1"/>
+          <p:nvPr/>
+        </p:nvSpPr>
+        <p:spPr>
+          <a:xfrm>
+            <a:off x="9957816" y="2103120"/>
+            <a:ext cx="7607808" cy="512063"/>
+          </a:xfrm>
+          <a:prstGeom prst="rect">
+            <a:avLst/>
+          </a:prstGeom>
+          <a:noFill/>
+        </p:spPr>
+        <p:txBody>
+          <a:bodyPr wrap="square" anchor="ctr" lIns="0" rIns="0" tIns="0" bIns="0">
+            <a:spAutoFit/>
+          </a:bodyPr>
+          <a:lstStyle/>
+          <a:p>
+            <a:pPr algn="l">
+              <a:lnSpc>
+                <a:spcPct val="110000"/>
+              </a:lnSpc>
+            </a:pPr>
+            <a:r>
+              <a:rPr sz="2400" b="1">
+                <a:solidFill>
+                  <a:srgbClr val="1A1A1A"/>
+                </a:solidFill>
+                <a:latin typeface="Arial"/>
+                <a:ea typeface="Arial"/>
+              </a:rPr>
+              <a:t>기회: 추론의 병목은 메모리</a:t>
+            </a:r>
+          </a:p>
+        </p:txBody>
+      </p:sp>
+      <p:sp>
+        <p:nvSpPr>
+          <p:cNvPr id="13" name="Rectangle 12"/>
+          <p:cNvSpPr/>
+          <p:nvPr/>
+        </p:nvSpPr>
+        <p:spPr>
+          <a:xfrm>
+            <a:off x="722376" y="8778240"/>
+            <a:ext cx="16843248" cy="731520"/>
+          </a:xfrm>
+          <a:prstGeom prst="rect">
+            <a:avLst/>
+          </a:prstGeom>
+          <a:solidFill>
+            <a:srgbClr val="3C4FA5"/>
+          </a:solidFill>
+          <a:ln>
+            <a:noFill/>
+          </a:ln>
+          <a:effectLst/>
+        </p:spPr>
+        <p:style>
+          <a:lnRef idx="1">
+            <a:schemeClr val="accent1"/>
+          </a:lnRef>
+          <a:fillRef idx="3">
+            <a:schemeClr val="accent1"/>
+          </a:fillRef>
+          <a:effectRef idx="2">
+            <a:schemeClr val="accent1"/>
+          </a:effectRef>
+          <a:fontRef idx="minor">
+            <a:schemeClr val="lt1"/>
+          </a:fontRef>
+        </p:style>
+        <p:txBody>
+          <a:bodyPr rtlCol="0" anchor="ctr"/>
+          <a:lstStyle/>
+          <a:p>
+            <a:pPr algn="ctr"/>
+          </a:p>
+        </p:txBody>
+      </p:sp>
+      <p:sp>
+        <p:nvSpPr>
+          <p:cNvPr id="14" name="TextBox 13"/>
+          <p:cNvSpPr txBox="1"/>
+          <p:nvPr/>
+        </p:nvSpPr>
+        <p:spPr>
+          <a:xfrm>
+            <a:off x="1088136" y="8778240"/>
+            <a:ext cx="1234440" cy="731520"/>
+          </a:xfrm>
+          <a:prstGeom prst="rect">
+            <a:avLst/>
+          </a:prstGeom>
+          <a:noFill/>
+        </p:spPr>
+        <p:txBody>
+          <a:bodyPr wrap="square" anchor="ctr" lIns="0" rIns="0" tIns="0" bIns="0">
+            <a:spAutoFit/>
+          </a:bodyPr>
+          <a:lstStyle/>
+          <a:p>
+            <a:pPr algn="l">
+              <a:lnSpc>
+                <a:spcPct val="110000"/>
+              </a:lnSpc>
+            </a:pPr>
+            <a:r>
+              <a:rPr sz="2000" b="0">
+                <a:solidFill>
+                  <a:srgbClr val="C0CAEC"/>
+                </a:solidFill>
+                <a:latin typeface="Arial"/>
+                <a:ea typeface="Arial"/>
+              </a:rPr>
+              <a:t>현실</a:t>
+            </a:r>
+          </a:p>
+        </p:txBody>
+      </p:sp>
+      <p:sp>
+        <p:nvSpPr>
+          <p:cNvPr id="15" name="TextBox 14"/>
+          <p:cNvSpPr txBox="1"/>
+          <p:nvPr/>
+        </p:nvSpPr>
+        <p:spPr>
+          <a:xfrm>
+            <a:off x="2322576" y="8778240"/>
+            <a:ext cx="15060168" cy="731520"/>
+          </a:xfrm>
+          <a:prstGeom prst="rect">
+            <a:avLst/>
+          </a:prstGeom>
+          <a:noFill/>
+        </p:spPr>
+        <p:txBody>
+          <a:bodyPr wrap="square" anchor="ctr" lIns="0" rIns="0" tIns="0" bIns="0">
+            <a:spAutoFit/>
+          </a:bodyPr>
+          <a:lstStyle/>
+          <a:p>
+            <a:pPr algn="l">
+              <a:lnSpc>
+                <a:spcPct val="110000"/>
+              </a:lnSpc>
+            </a:pPr>
+            <a:r>
+              <a:rPr sz="2400" b="1">
+                <a:solidFill>
+                  <a:srgbClr val="FFFFFF"/>
+                </a:solidFill>
+                <a:latin typeface="Arial"/>
+                <a:ea typeface="Arial"/>
+              </a:rPr>
+              <a:t>Shrink만으로는 격차를 지킬 수 없다. 차별화는 AI 추론의 메모리 병목에서 찾는다</a:t>
+            </a:r>
+          </a:p>
+        </p:txBody>
+      </p:sp>
+      <p:pic>
+        <p:nvPicPr>
+          <p:cNvPr id="16" name="Picture 15" descr="node_simple_cadence.png"/>
+          <p:cNvPicPr>
+            <a:picLocks noChangeAspect="1"/>
+          </p:cNvPicPr>
+          <p:nvPr/>
+        </p:nvPicPr>
+        <p:blipFill>
+          <a:blip r:embed="rId2"/>
+          <a:stretch>
+            <a:fillRect/>
+          </a:stretch>
+        </p:blipFill>
+        <p:spPr>
+          <a:xfrm>
+            <a:off x="722376" y="2724912"/>
+            <a:ext cx="8010144" cy="5852160"/>
+          </a:xfrm>
+          <a:prstGeom prst="rect">
+            <a:avLst/>
+          </a:prstGeom>
+        </p:spPr>
+      </p:pic>
+      <p:pic>
+        <p:nvPicPr>
+          <p:cNvPr id="17" name="Picture 16" descr="tank_big.png"/>
+          <p:cNvPicPr>
+            <a:picLocks noChangeAspect="1"/>
+          </p:cNvPicPr>
+          <p:nvPr/>
+        </p:nvPicPr>
+        <p:blipFill>
+          <a:blip r:embed="rId3"/>
+          <a:stretch>
+            <a:fillRect/>
+          </a:stretch>
+        </p:blipFill>
+        <p:spPr>
+          <a:xfrm>
+            <a:off x="9372600" y="2724912"/>
+            <a:ext cx="8193024" cy="3749039"/>
+          </a:xfrm>
+          <a:prstGeom prst="rect">
+            <a:avLst/>
+          </a:prstGeom>
+        </p:spPr>
+      </p:pic>
+      <p:pic>
+        <p:nvPicPr>
+          <p:cNvPr id="18" name="Picture 17" descr="render_hbm.png"/>
+          <p:cNvPicPr>
+            <a:picLocks noChangeAspect="1"/>
+          </p:cNvPicPr>
+          <p:nvPr/>
+        </p:nvPicPr>
+        <p:blipFill>
+          <a:blip r:embed="rId4"/>
+          <a:stretch>
+            <a:fillRect/>
+          </a:stretch>
+        </p:blipFill>
+        <p:spPr>
+          <a:xfrm>
+            <a:off x="9875520" y="3757352"/>
+            <a:ext cx="2103120" cy="1537854"/>
+          </a:xfrm>
+          <a:prstGeom prst="rect">
+            <a:avLst/>
+          </a:prstGeom>
+        </p:spPr>
+      </p:pic>
+      <p:pic>
+        <p:nvPicPr>
+          <p:cNvPr id="19" name="Picture 18" descr="render_hbm.png"/>
+          <p:cNvPicPr>
+            <a:picLocks noChangeAspect="1"/>
+          </p:cNvPicPr>
+          <p:nvPr/>
+        </p:nvPicPr>
+        <p:blipFill>
+          <a:blip r:embed="rId4"/>
+          <a:stretch>
+            <a:fillRect/>
+          </a:stretch>
+        </p:blipFill>
+        <p:spPr>
+          <a:xfrm>
+            <a:off x="9424745" y="6784848"/>
+            <a:ext cx="1313028" cy="960120"/>
+          </a:xfrm>
+          <a:prstGeom prst="rect">
+            <a:avLst/>
+          </a:prstGeom>
+        </p:spPr>
+      </p:pic>
+      <p:sp>
+        <p:nvSpPr>
+          <p:cNvPr id="20" name="TextBox 19"/>
+          <p:cNvSpPr txBox="1"/>
+          <p:nvPr/>
+        </p:nvSpPr>
+        <p:spPr>
+          <a:xfrm>
+            <a:off x="9189720" y="7790688"/>
+            <a:ext cx="1783080" cy="329184"/>
+          </a:xfrm>
+          <a:prstGeom prst="rect">
+            <a:avLst/>
+          </a:prstGeom>
+          <a:noFill/>
+        </p:spPr>
+        <p:txBody>
+          <a:bodyPr wrap="square" anchor="ctr" lIns="0" rIns="0" tIns="0" bIns="0">
+            <a:spAutoFit/>
+          </a:bodyPr>
+          <a:lstStyle/>
+          <a:p>
+            <a:pPr algn="ctr">
+              <a:lnSpc>
+                <a:spcPct val="110000"/>
+              </a:lnSpc>
+            </a:pPr>
+            <a:r>
+              <a:rPr sz="2000" b="1">
+                <a:solidFill>
+                  <a:srgbClr val="1A1A1A"/>
+                </a:solidFill>
+                <a:latin typeface="Arial"/>
+                <a:ea typeface="Arial"/>
+              </a:rPr>
+              <a:t>HBM</a:t>
+            </a:r>
+          </a:p>
+        </p:txBody>
+      </p:sp>
+      <p:sp>
+        <p:nvSpPr>
+          <p:cNvPr id="21" name="Right Arrow 20"/>
+          <p:cNvSpPr/>
+          <p:nvPr/>
+        </p:nvSpPr>
+        <p:spPr>
+          <a:xfrm>
+            <a:off x="10844784" y="7132320"/>
+            <a:ext cx="374904" cy="274320"/>
+          </a:xfrm>
+          <a:prstGeom prst="rightArrow">
+            <a:avLst/>
+          </a:prstGeom>
+          <a:solidFill>
+            <a:srgbClr val="D93025"/>
+          </a:solidFill>
+          <a:ln>
+            <a:noFill/>
+          </a:ln>
+          <a:effectLst/>
+        </p:spPr>
+        <p:style>
+          <a:lnRef idx="1">
+            <a:schemeClr val="accent1"/>
+          </a:lnRef>
+          <a:fillRef idx="3">
+            <a:schemeClr val="accent1"/>
+          </a:fillRef>
+          <a:effectRef idx="2">
+            <a:schemeClr val="accent1"/>
+          </a:effectRef>
+          <a:fontRef idx="minor">
+            <a:schemeClr val="lt1"/>
+          </a:fontRef>
+        </p:style>
+        <p:txBody>
+          <a:bodyPr rtlCol="0" anchor="ctr"/>
+          <a:lstStyle/>
+          <a:p>
+            <a:pPr algn="ctr"/>
+          </a:p>
+        </p:txBody>
+      </p:sp>
+      <p:pic>
+        <p:nvPicPr>
+          <p:cNvPr id="22" name="Picture 21" descr="render_dram.png"/>
+          <p:cNvPicPr>
+            <a:picLocks noChangeAspect="1"/>
+          </p:cNvPicPr>
+          <p:nvPr/>
+        </p:nvPicPr>
+        <p:blipFill>
+          <a:blip r:embed="rId5"/>
+          <a:stretch>
+            <a:fillRect/>
+          </a:stretch>
+        </p:blipFill>
+        <p:spPr>
+          <a:xfrm>
+            <a:off x="11274552" y="6998823"/>
+            <a:ext cx="1417320" cy="532169"/>
+          </a:xfrm>
+          <a:prstGeom prst="rect">
+            <a:avLst/>
+          </a:prstGeom>
+        </p:spPr>
+      </p:pic>
+      <p:sp>
+        <p:nvSpPr>
+          <p:cNvPr id="23" name="TextBox 22"/>
+          <p:cNvSpPr txBox="1"/>
+          <p:nvPr/>
+        </p:nvSpPr>
+        <p:spPr>
+          <a:xfrm>
+            <a:off x="11091672" y="7790688"/>
+            <a:ext cx="1783080" cy="329184"/>
+          </a:xfrm>
+          <a:prstGeom prst="rect">
+            <a:avLst/>
+          </a:prstGeom>
+          <a:noFill/>
+        </p:spPr>
+        <p:txBody>
+          <a:bodyPr wrap="square" anchor="ctr" lIns="0" rIns="0" tIns="0" bIns="0">
+            <a:spAutoFit/>
+          </a:bodyPr>
+          <a:lstStyle/>
+          <a:p>
+            <a:pPr algn="ctr">
+              <a:lnSpc>
+                <a:spcPct val="110000"/>
+              </a:lnSpc>
+            </a:pPr>
+            <a:r>
+              <a:rPr sz="2000" b="1">
+                <a:solidFill>
+                  <a:srgbClr val="1A1A1A"/>
+                </a:solidFill>
+                <a:latin typeface="Arial"/>
+                <a:ea typeface="Arial"/>
+              </a:rPr>
+              <a:t>DRAM</a:t>
+            </a:r>
+          </a:p>
+        </p:txBody>
+      </p:sp>
+      <p:sp>
+        <p:nvSpPr>
+          <p:cNvPr id="24" name="Right Arrow 23"/>
+          <p:cNvSpPr/>
+          <p:nvPr/>
+        </p:nvSpPr>
+        <p:spPr>
+          <a:xfrm>
+            <a:off x="12746736" y="7132320"/>
+            <a:ext cx="374904" cy="274320"/>
+          </a:xfrm>
+          <a:prstGeom prst="rightArrow">
+            <a:avLst/>
+          </a:prstGeom>
+          <a:solidFill>
+            <a:srgbClr val="8A8A8A"/>
+          </a:solidFill>
+          <a:ln>
+            <a:noFill/>
+          </a:ln>
+          <a:effectLst/>
+        </p:spPr>
+        <p:style>
+          <a:lnRef idx="1">
+            <a:schemeClr val="accent1"/>
+          </a:lnRef>
+          <a:fillRef idx="3">
+            <a:schemeClr val="accent1"/>
+          </a:fillRef>
+          <a:effectRef idx="2">
+            <a:schemeClr val="accent1"/>
+          </a:effectRef>
+          <a:fontRef idx="minor">
+            <a:schemeClr val="lt1"/>
+          </a:fontRef>
+        </p:style>
+        <p:txBody>
+          <a:bodyPr rtlCol="0" anchor="ctr"/>
+          <a:lstStyle/>
+          <a:p>
+            <a:pPr algn="ctr"/>
+          </a:p>
+        </p:txBody>
+      </p:sp>
+      <p:pic>
+        <p:nvPicPr>
+          <p:cNvPr id="25" name="Picture 24" descr="render_server.png"/>
+          <p:cNvPicPr>
+            <a:picLocks noChangeAspect="1"/>
+          </p:cNvPicPr>
+          <p:nvPr/>
+        </p:nvPicPr>
+        <p:blipFill>
+          <a:blip r:embed="rId6"/>
+          <a:stretch>
+            <a:fillRect/>
+          </a:stretch>
+        </p:blipFill>
+        <p:spPr>
+          <a:xfrm>
+            <a:off x="13176504" y="6847856"/>
+            <a:ext cx="1417320" cy="834103"/>
+          </a:xfrm>
+          <a:prstGeom prst="rect">
+            <a:avLst/>
+          </a:prstGeom>
+        </p:spPr>
+      </p:pic>
+      <p:sp>
+        <p:nvSpPr>
+          <p:cNvPr id="26" name="TextBox 25"/>
+          <p:cNvSpPr txBox="1"/>
+          <p:nvPr/>
+        </p:nvSpPr>
+        <p:spPr>
+          <a:xfrm>
+            <a:off x="12993624" y="7790688"/>
+            <a:ext cx="1783080" cy="329184"/>
+          </a:xfrm>
+          <a:prstGeom prst="rect">
+            <a:avLst/>
+          </a:prstGeom>
+          <a:noFill/>
+        </p:spPr>
+        <p:txBody>
+          <a:bodyPr wrap="square" anchor="ctr" lIns="0" rIns="0" tIns="0" bIns="0">
+            <a:spAutoFit/>
+          </a:bodyPr>
+          <a:lstStyle/>
+          <a:p>
+            <a:pPr algn="ctr">
+              <a:lnSpc>
+                <a:spcPct val="110000"/>
+              </a:lnSpc>
+            </a:pPr>
+            <a:r>
+              <a:rPr sz="2000" b="1">
+                <a:solidFill>
+                  <a:srgbClr val="1A1A1A"/>
+                </a:solidFill>
+                <a:latin typeface="Arial"/>
+                <a:ea typeface="Arial"/>
+              </a:rPr>
+              <a:t>SSD · 서버</a:t>
+            </a:r>
+          </a:p>
+        </p:txBody>
+      </p:sp>
+      <p:sp>
+        <p:nvSpPr>
+          <p:cNvPr id="27" name="TextBox 26"/>
+          <p:cNvSpPr txBox="1"/>
+          <p:nvPr/>
+        </p:nvSpPr>
+        <p:spPr>
+          <a:xfrm>
+            <a:off x="9372600" y="8174736"/>
+            <a:ext cx="5257800" cy="365760"/>
+          </a:xfrm>
+          <a:prstGeom prst="rect">
+            <a:avLst/>
+          </a:prstGeom>
+          <a:noFill/>
+        </p:spPr>
+        <p:txBody>
+          <a:bodyPr wrap="square" anchor="ctr" lIns="0" rIns="0" tIns="0" bIns="0">
+            <a:spAutoFit/>
+          </a:bodyPr>
+          <a:lstStyle/>
+          <a:p>
+            <a:pPr algn="ctr">
+              <a:lnSpc>
+                <a:spcPct val="110000"/>
+              </a:lnSpc>
+            </a:pPr>
+            <a:r>
+              <a:rPr sz="2000" b="1">
+                <a:solidFill>
+                  <a:srgbClr val="D93025"/>
+                </a:solidFill>
+                <a:latin typeface="Arial"/>
+                <a:ea typeface="Arial"/>
+              </a:rPr>
+              <a:t>넘친 KV는 아래 계층으로</a:t>
+            </a:r>
+          </a:p>
+        </p:txBody>
+      </p:sp>
+      <p:sp>
+        <p:nvSpPr>
+          <p:cNvPr id="28" name="Rounded Rectangle 27"/>
+          <p:cNvSpPr/>
+          <p:nvPr/>
+        </p:nvSpPr>
+        <p:spPr>
+          <a:xfrm>
+            <a:off x="15005304" y="6784848"/>
+            <a:ext cx="2560320" cy="1755648"/>
+          </a:xfrm>
+          <a:prstGeom prst="roundRect">
+            <a:avLst>
+              <a:gd name="adj" fmla="val 4166"/>
+            </a:avLst>
+          </a:prstGeom>
+          <a:solidFill>
+            <a:srgbClr val="FFFFFF"/>
+          </a:solidFill>
+          <a:ln w="19050">
+            <a:solidFill>
+              <a:srgbClr val="D93025"/>
+            </a:solidFill>
+          </a:ln>
+          <a:effectLst/>
+        </p:spPr>
+        <p:style>
+          <a:lnRef idx="1">
+            <a:schemeClr val="accent1"/>
+          </a:lnRef>
+          <a:fillRef idx="3">
+            <a:schemeClr val="accent1"/>
+          </a:fillRef>
+          <a:effectRef idx="2">
+            <a:schemeClr val="accent1"/>
+          </a:effectRef>
+          <a:fontRef idx="minor">
+            <a:schemeClr val="lt1"/>
+          </a:fontRef>
+        </p:style>
+        <p:txBody>
+          <a:bodyPr rtlCol="0" anchor="ctr"/>
+          <a:lstStyle/>
+          <a:p>
+            <a:pPr algn="ctr"/>
+          </a:p>
+        </p:txBody>
+      </p:sp>
+      <p:sp>
+        <p:nvSpPr>
+          <p:cNvPr id="29" name="TextBox 28"/>
+          <p:cNvSpPr txBox="1"/>
+          <p:nvPr/>
+        </p:nvSpPr>
+        <p:spPr>
+          <a:xfrm>
+            <a:off x="15005304" y="6876288"/>
+            <a:ext cx="2560320" cy="310896"/>
+          </a:xfrm>
+          <a:prstGeom prst="rect">
+            <a:avLst/>
+          </a:prstGeom>
+          <a:noFill/>
+        </p:spPr>
+        <p:txBody>
+          <a:bodyPr wrap="square" anchor="ctr" lIns="0" rIns="0" tIns="0" bIns="0">
+            <a:spAutoFit/>
+          </a:bodyPr>
+          <a:lstStyle/>
+          <a:p>
+            <a:pPr algn="ctr">
+              <a:lnSpc>
+                <a:spcPct val="110000"/>
+              </a:lnSpc>
+            </a:pPr>
+            <a:r>
+              <a:rPr sz="1800" b="1">
+                <a:solidFill>
+                  <a:srgbClr val="1A1A1A"/>
+                </a:solidFill>
+                <a:latin typeface="Arial"/>
+                <a:ea typeface="Arial"/>
+              </a:rPr>
+              <a:t>메모리 공급</a:t>
+            </a:r>
+          </a:p>
+        </p:txBody>
+      </p:sp>
+      <p:sp>
+        <p:nvSpPr>
+          <p:cNvPr id="30" name="TextBox 29"/>
+          <p:cNvSpPr txBox="1"/>
+          <p:nvPr/>
+        </p:nvSpPr>
+        <p:spPr>
+          <a:xfrm>
+            <a:off x="15005304" y="7205472"/>
+            <a:ext cx="2560320" cy="731520"/>
+          </a:xfrm>
+          <a:prstGeom prst="rect">
+            <a:avLst/>
+          </a:prstGeom>
+          <a:noFill/>
+        </p:spPr>
+        <p:txBody>
+          <a:bodyPr wrap="square" anchor="ctr" lIns="0" rIns="0" tIns="0" bIns="0">
+            <a:spAutoFit/>
+          </a:bodyPr>
+          <a:lstStyle/>
+          <a:p>
+            <a:pPr algn="ctr">
+              <a:lnSpc>
+                <a:spcPct val="110000"/>
+              </a:lnSpc>
+            </a:pPr>
+            <a:r>
+              <a:rPr sz="4800" b="1">
+                <a:solidFill>
+                  <a:srgbClr val="D93025"/>
+                </a:solidFill>
+                <a:latin typeface="Arial"/>
+                <a:ea typeface="Arial"/>
+              </a:rPr>
+              <a:t>2028</a:t>
+            </a:r>
+          </a:p>
+        </p:txBody>
+      </p:sp>
+      <p:sp>
+        <p:nvSpPr>
+          <p:cNvPr id="31" name="TextBox 30"/>
+          <p:cNvSpPr txBox="1"/>
+          <p:nvPr/>
+        </p:nvSpPr>
+        <p:spPr>
+          <a:xfrm>
+            <a:off x="15005304" y="8138160"/>
+            <a:ext cx="2560320" cy="310896"/>
+          </a:xfrm>
+          <a:prstGeom prst="rect">
+            <a:avLst/>
+          </a:prstGeom>
+          <a:noFill/>
+        </p:spPr>
+        <p:txBody>
+          <a:bodyPr wrap="square" anchor="ctr" lIns="0" rIns="0" tIns="0" bIns="0">
+            <a:spAutoFit/>
+          </a:bodyPr>
+          <a:lstStyle/>
+          <a:p>
+            <a:pPr algn="ctr">
+              <a:lnSpc>
+                <a:spcPct val="110000"/>
+              </a:lnSpc>
+            </a:pPr>
+            <a:r>
+              <a:rPr sz="1600" b="0">
+                <a:solidFill>
+                  <a:srgbClr val="555555"/>
+                </a:solidFill>
+                <a:latin typeface="Arial"/>
+                <a:ea typeface="Arial"/>
+              </a:rPr>
+              <a:t>신규 팹 실질 출하</a:t>
+            </a:r>
+          </a:p>
+        </p:txBody>
+      </p:sp>
+      <p:sp>
+        <p:nvSpPr>
+          <p:cNvPr id="32" name="TextBox 31"/>
+          <p:cNvSpPr txBox="1"/>
+          <p:nvPr/>
+        </p:nvSpPr>
+        <p:spPr>
+          <a:xfrm>
+            <a:off x="722376" y="9601200"/>
+            <a:ext cx="15453359" cy="310896"/>
+          </a:xfrm>
+          <a:prstGeom prst="rect">
+            <a:avLst/>
+          </a:prstGeom>
+          <a:noFill/>
+        </p:spPr>
+        <p:txBody>
+          <a:bodyPr wrap="square" anchor="t" lIns="0" rIns="0" tIns="0" bIns="0">
+            <a:spAutoFit/>
+          </a:bodyPr>
+          <a:lstStyle/>
+          <a:p>
+            <a:pPr algn="l">
+              <a:lnSpc>
+                <a:spcPct val="110000"/>
+              </a:lnSpc>
+            </a:pPr>
+            <a:r>
+              <a:rPr sz="1500" b="0">
+                <a:solidFill>
+                  <a:srgbClr val="555555"/>
+                </a:solidFill>
+                <a:latin typeface="Arial"/>
+                <a:ea typeface="Arial"/>
+              </a:rPr>
+              <a:t>출처: ITRS · TechInsights · Fab Tracker Q2'26 · Digitimes / Llama 3.1 설정 산식 · Google I/O · TrendForce 2026-07 · 산술은 가정 의존 · 부품은 3D 렌더 · 상세 근거는 시안 A~C</a:t>
+            </a:r>
+          </a:p>
+        </p:txBody>
+      </p:sp>
+      <p:sp>
+        <p:nvSpPr>
+          <p:cNvPr id="33" name="TextBox 32"/>
+          <p:cNvSpPr txBox="1"/>
+          <p:nvPr/>
+        </p:nvSpPr>
+        <p:spPr>
+          <a:xfrm>
+            <a:off x="16102584" y="9601200"/>
+            <a:ext cx="1463040" cy="310896"/>
+          </a:xfrm>
+          <a:prstGeom prst="rect">
+            <a:avLst/>
+          </a:prstGeom>
+          <a:noFill/>
+        </p:spPr>
+        <p:txBody>
+          <a:bodyPr wrap="square" anchor="t" lIns="0" rIns="0" tIns="0" bIns="0">
+            <a:spAutoFit/>
+          </a:bodyPr>
+          <a:lstStyle/>
+          <a:p>
+            <a:pPr algn="r">
+              <a:lnSpc>
+                <a:spcPct val="110000"/>
+              </a:lnSpc>
+            </a:pPr>
+            <a:r>
+              <a:rPr sz="1600" b="1">
+                <a:solidFill>
+                  <a:srgbClr val="555555"/>
+                </a:solidFill>
+                <a:latin typeface="Arial"/>
+                <a:ea typeface="Arial"/>
+              </a:rPr>
+              <a:t>시안 C2</a:t>
             </a:r>
           </a:p>
         </p:txBody>

</xml_diff>